<commit_message>
docs(slides): fix card overflow, banner, legible req graphs, clean arrows, tight boxes
</commit_message>
<xml_diff>
--- a/slides/FYDP-I_Defect-to-Delivery.pptx
+++ b/slides/FYDP-I_Defect-to-Delivery.pptx
@@ -5171,7 +5171,7 @@
         <p:spPr>
           <a:xfrm>
             <a:off x="548640" y="1463040"/>
-            <a:ext cx="2651760" cy="2834640"/>
+            <a:ext cx="2651760" cy="2286000"/>
           </a:xfrm>
           <a:prstGeom prst="roundRect">
             <a:avLst>
@@ -5313,7 +5313,7 @@
         <p:spPr>
           <a:xfrm>
             <a:off x="1417319" y="1719072"/>
-            <a:ext cx="1600200" cy="2423160"/>
+            <a:ext cx="1600200" cy="1874519"/>
           </a:xfrm>
           <a:prstGeom prst="rect">
             <a:avLst/>
@@ -5322,7 +5322,7 @@
         </p:spPr>
         <p:txBody>
           <a:bodyPr wrap="square">
-            <a:spAutoFit/>
+            <a:normAutofit/>
           </a:bodyPr>
           <a:lstStyle/>
           <a:p>
@@ -5371,7 +5371,7 @@
         <p:spPr>
           <a:xfrm>
             <a:off x="3328416" y="1463040"/>
-            <a:ext cx="2651760" cy="2834640"/>
+            <a:ext cx="2651760" cy="2286000"/>
           </a:xfrm>
           <a:prstGeom prst="roundRect">
             <a:avLst>
@@ -5513,7 +5513,7 @@
         <p:spPr>
           <a:xfrm>
             <a:off x="4197096" y="1719072"/>
-            <a:ext cx="1600200" cy="2423160"/>
+            <a:ext cx="1600200" cy="1874519"/>
           </a:xfrm>
           <a:prstGeom prst="rect">
             <a:avLst/>
@@ -5522,7 +5522,7 @@
         </p:spPr>
         <p:txBody>
           <a:bodyPr wrap="square">
-            <a:spAutoFit/>
+            <a:normAutofit/>
           </a:bodyPr>
           <a:lstStyle/>
           <a:p>
@@ -5571,7 +5571,7 @@
         <p:spPr>
           <a:xfrm>
             <a:off x="6108192" y="1463040"/>
-            <a:ext cx="2651760" cy="2834640"/>
+            <a:ext cx="2651760" cy="2286000"/>
           </a:xfrm>
           <a:prstGeom prst="roundRect">
             <a:avLst>
@@ -5713,7 +5713,7 @@
         <p:spPr>
           <a:xfrm>
             <a:off x="6976872" y="1719072"/>
-            <a:ext cx="1600200" cy="2423160"/>
+            <a:ext cx="1600200" cy="1874519"/>
           </a:xfrm>
           <a:prstGeom prst="rect">
             <a:avLst/>
@@ -5722,7 +5722,7 @@
         </p:spPr>
         <p:txBody>
           <a:bodyPr wrap="square">
-            <a:spAutoFit/>
+            <a:normAutofit/>
           </a:bodyPr>
           <a:lstStyle/>
           <a:p>
@@ -5771,7 +5771,7 @@
         <p:spPr>
           <a:xfrm>
             <a:off x="8887968" y="1463040"/>
-            <a:ext cx="2651760" cy="2834640"/>
+            <a:ext cx="2651760" cy="2286000"/>
           </a:xfrm>
           <a:prstGeom prst="roundRect">
             <a:avLst>
@@ -5913,7 +5913,7 @@
         <p:spPr>
           <a:xfrm>
             <a:off x="9756648" y="1719072"/>
-            <a:ext cx="1600200" cy="2423160"/>
+            <a:ext cx="1600200" cy="1874519"/>
           </a:xfrm>
           <a:prstGeom prst="rect">
             <a:avLst/>
@@ -5922,7 +5922,7 @@
         </p:spPr>
         <p:txBody>
           <a:bodyPr wrap="square">
-            <a:spAutoFit/>
+            <a:normAutofit/>
           </a:bodyPr>
           <a:lstStyle/>
           <a:p>
@@ -6230,8 +6230,8 @@
         </p:blipFill>
         <p:spPr>
           <a:xfrm>
-            <a:off x="320040" y="1508760"/>
-            <a:ext cx="5623560" cy="3172968"/>
+            <a:off x="320040" y="1463040"/>
+            <a:ext cx="5623560" cy="3566160"/>
           </a:xfrm>
           <a:prstGeom prst="rect">
             <a:avLst/>
@@ -6254,8 +6254,8 @@
         </p:blipFill>
         <p:spPr>
           <a:xfrm>
-            <a:off x="6245352" y="1508760"/>
-            <a:ext cx="5623560" cy="3172968"/>
+            <a:off x="6245352" y="1463040"/>
+            <a:ext cx="5623560" cy="3566160"/>
           </a:xfrm>
           <a:prstGeom prst="rect">
             <a:avLst/>
@@ -6270,8 +6270,8 @@
         </p:nvSpPr>
         <p:spPr>
           <a:xfrm>
-            <a:off x="320040" y="4754880"/>
-            <a:ext cx="5623560" cy="457200"/>
+            <a:off x="320040" y="5074920"/>
+            <a:ext cx="5623560" cy="411480"/>
           </a:xfrm>
           <a:prstGeom prst="rect">
             <a:avLst/>
@@ -6305,8 +6305,8 @@
         </p:nvSpPr>
         <p:spPr>
           <a:xfrm>
-            <a:off x="6245352" y="4754880"/>
-            <a:ext cx="5623560" cy="457200"/>
+            <a:off x="6245352" y="5074920"/>
+            <a:ext cx="5623560" cy="411480"/>
           </a:xfrm>
           <a:prstGeom prst="rect">
             <a:avLst/>
@@ -6340,8 +6340,8 @@
         </p:nvSpPr>
         <p:spPr>
           <a:xfrm>
-            <a:off x="548640" y="5257800"/>
-            <a:ext cx="11064240" cy="914400"/>
+            <a:off x="548640" y="5532120"/>
+            <a:ext cx="11064240" cy="731520"/>
           </a:xfrm>
           <a:prstGeom prst="rect">
             <a:avLst/>
@@ -6363,13 +6363,13 @@
               </a:spcAft>
             </a:pPr>
             <a:r>
-              <a:rPr sz="1350" b="0" i="0">
+              <a:rPr sz="1300" b="0" i="0">
                 <a:solidFill>
                   <a:srgbClr val="1F2937"/>
                 </a:solidFill>
                 <a:latin typeface="Calibri"/>
               </a:rPr>
-              <a:t>▪  Seven Pipeline Functions From Image Input To Dashboard Display; Six Quality Attributes With Measurable Targets (≥15 FPS, mAP Tracking, Zero-Overlap Splits).</a:t>
+              <a:t>▪  Six Pipeline Function Groups From Image Input To Dashboard Display, Plus Six Quality Attributes With Measurable Targets (≥15 FPS, mAP Tracking, Zero-Overlap Splits).</a:t>
             </a:r>
           </a:p>
         </p:txBody>
@@ -7584,7 +7584,7 @@
         <p:spPr>
           <a:xfrm>
             <a:off x="548640" y="1463040"/>
-            <a:ext cx="5394960" cy="4206240"/>
+            <a:ext cx="5394960" cy="3291840"/>
           </a:xfrm>
           <a:prstGeom prst="roundRect">
             <a:avLst>
@@ -7726,7 +7726,7 @@
         <p:spPr>
           <a:xfrm>
             <a:off x="1417319" y="1719072"/>
-            <a:ext cx="4343400" cy="3794759"/>
+            <a:ext cx="4343400" cy="2880360"/>
           </a:xfrm>
           <a:prstGeom prst="rect">
             <a:avLst/>
@@ -7735,7 +7735,7 @@
         </p:spPr>
         <p:txBody>
           <a:bodyPr wrap="square">
-            <a:spAutoFit/>
+            <a:normAutofit/>
           </a:bodyPr>
           <a:lstStyle/>
           <a:p>
@@ -7822,7 +7822,7 @@
         <p:spPr>
           <a:xfrm>
             <a:off x="6245352" y="1463040"/>
-            <a:ext cx="5394960" cy="4206240"/>
+            <a:ext cx="5394960" cy="3291840"/>
           </a:xfrm>
           <a:prstGeom prst="roundRect">
             <a:avLst>
@@ -7964,7 +7964,7 @@
         <p:spPr>
           <a:xfrm>
             <a:off x="7114032" y="1719072"/>
-            <a:ext cx="4343400" cy="3794759"/>
+            <a:ext cx="4343400" cy="2880360"/>
           </a:xfrm>
           <a:prstGeom prst="rect">
             <a:avLst/>
@@ -7973,7 +7973,7 @@
         </p:spPr>
         <p:txBody>
           <a:bodyPr wrap="square">
-            <a:spAutoFit/>
+            <a:normAutofit/>
           </a:bodyPr>
           <a:lstStyle/>
           <a:p>
@@ -8346,7 +8346,9 @@
           </a:fontRef>
         </p:style>
         <p:txBody>
-          <a:bodyPr rtlCol="0" anchor="ctr" wrap="square"/>
+          <a:bodyPr rtlCol="0" anchor="ctr" wrap="square">
+            <a:normAutofit/>
+          </a:bodyPr>
           <a:lstStyle/>
           <a:p>
             <a:pPr algn="ctr"/>
@@ -8403,7 +8405,9 @@
           </a:fontRef>
         </p:style>
         <p:txBody>
-          <a:bodyPr rtlCol="0" anchor="ctr" wrap="square"/>
+          <a:bodyPr rtlCol="0" anchor="ctr" wrap="square">
+            <a:normAutofit/>
+          </a:bodyPr>
           <a:lstStyle/>
           <a:p>
             <a:pPr algn="ctr"/>
@@ -8498,7 +8502,9 @@
           </a:fontRef>
         </p:style>
         <p:txBody>
-          <a:bodyPr rtlCol="0" anchor="ctr" wrap="square"/>
+          <a:bodyPr rtlCol="0" anchor="ctr" wrap="square">
+            <a:normAutofit/>
+          </a:bodyPr>
           <a:lstStyle/>
           <a:p>
             <a:pPr algn="ctr"/>
@@ -8593,7 +8599,9 @@
           </a:fontRef>
         </p:style>
         <p:txBody>
-          <a:bodyPr rtlCol="0" anchor="ctr" wrap="square"/>
+          <a:bodyPr rtlCol="0" anchor="ctr" wrap="square">
+            <a:normAutofit/>
+          </a:bodyPr>
           <a:lstStyle/>
           <a:p>
             <a:pPr algn="ctr"/>
@@ -8688,7 +8696,9 @@
           </a:fontRef>
         </p:style>
         <p:txBody>
-          <a:bodyPr rtlCol="0" anchor="ctr" wrap="square"/>
+          <a:bodyPr rtlCol="0" anchor="ctr" wrap="square">
+            <a:normAutofit/>
+          </a:bodyPr>
           <a:lstStyle/>
           <a:p>
             <a:pPr algn="ctr"/>
@@ -8782,7 +8792,9 @@
           </a:fontRef>
         </p:style>
         <p:txBody>
-          <a:bodyPr rtlCol="0" anchor="ctr" wrap="square"/>
+          <a:bodyPr rtlCol="0" anchor="ctr" wrap="square">
+            <a:normAutofit/>
+          </a:bodyPr>
           <a:lstStyle/>
           <a:p>
             <a:pPr algn="ctr"/>
@@ -8843,8 +8855,8 @@
         </p:nvCxnSpPr>
         <p:spPr>
           <a:xfrm>
-            <a:off x="10241280" y="4114800"/>
-            <a:ext cx="0" cy="1005840"/>
+            <a:off x="10241280" y="4133087"/>
+            <a:ext cx="0" cy="713233"/>
           </a:xfrm>
           <a:prstGeom prst="line">
             <a:avLst/>
@@ -8879,8 +8891,8 @@
         </p:nvCxnSpPr>
         <p:spPr>
           <a:xfrm flipH="1">
-            <a:off x="1371600" y="5138928"/>
-            <a:ext cx="8823960" cy="0"/>
+            <a:off x="1371600" y="4864608"/>
+            <a:ext cx="8851392" cy="0"/>
           </a:xfrm>
           <a:prstGeom prst="line">
             <a:avLst/>
@@ -8915,8 +8927,8 @@
         </p:nvCxnSpPr>
         <p:spPr>
           <a:xfrm flipV="1">
-            <a:off x="1353312" y="4160520"/>
-            <a:ext cx="0" cy="960120"/>
+            <a:off x="1353312" y="4133087"/>
+            <a:ext cx="0" cy="713233"/>
           </a:xfrm>
           <a:prstGeom prst="line">
             <a:avLst/>
@@ -8951,8 +8963,8 @@
         </p:nvSpPr>
         <p:spPr>
           <a:xfrm>
-            <a:off x="3291840" y="4892040"/>
-            <a:ext cx="5577840" cy="411480"/>
+            <a:off x="3291840" y="4224528"/>
+            <a:ext cx="5577840" cy="457200"/>
           </a:xfrm>
           <a:prstGeom prst="rect">
             <a:avLst/>
@@ -9270,7 +9282,9 @@
           </a:fontRef>
         </p:style>
         <p:txBody>
-          <a:bodyPr rtlCol="0" anchor="ctr" wrap="square"/>
+          <a:bodyPr rtlCol="0" anchor="ctr" wrap="square">
+            <a:normAutofit/>
+          </a:bodyPr>
           <a:lstStyle/>
           <a:p>
             <a:pPr algn="ctr"/>
@@ -9326,7 +9340,9 @@
           </a:fontRef>
         </p:style>
         <p:txBody>
-          <a:bodyPr rtlCol="0" anchor="ctr" wrap="square"/>
+          <a:bodyPr rtlCol="0" anchor="ctr" wrap="square">
+            <a:normAutofit/>
+          </a:bodyPr>
           <a:lstStyle/>
           <a:p>
             <a:pPr algn="ctr"/>
@@ -9382,7 +9398,9 @@
           </a:fontRef>
         </p:style>
         <p:txBody>
-          <a:bodyPr rtlCol="0" anchor="ctr" wrap="square"/>
+          <a:bodyPr rtlCol="0" anchor="ctr" wrap="square">
+            <a:normAutofit/>
+          </a:bodyPr>
           <a:lstStyle/>
           <a:p>
             <a:pPr algn="ctr"/>
@@ -9439,7 +9457,9 @@
           </a:fontRef>
         </p:style>
         <p:txBody>
-          <a:bodyPr rtlCol="0" anchor="ctr" wrap="square"/>
+          <a:bodyPr rtlCol="0" anchor="ctr" wrap="square">
+            <a:normAutofit/>
+          </a:bodyPr>
           <a:lstStyle/>
           <a:p>
             <a:pPr algn="ctr"/>
@@ -9494,7 +9514,9 @@
           </a:fontRef>
         </p:style>
         <p:txBody>
-          <a:bodyPr rtlCol="0" anchor="ctr" wrap="square"/>
+          <a:bodyPr rtlCol="0" anchor="ctr" wrap="square">
+            <a:normAutofit/>
+          </a:bodyPr>
           <a:lstStyle/>
           <a:p>
             <a:pPr algn="ctr"/>
@@ -9550,7 +9572,9 @@
           </a:fontRef>
         </p:style>
         <p:txBody>
-          <a:bodyPr rtlCol="0" anchor="ctr" wrap="square"/>
+          <a:bodyPr rtlCol="0" anchor="ctr" wrap="square">
+            <a:normAutofit/>
+          </a:bodyPr>
           <a:lstStyle/>
           <a:p>
             <a:pPr algn="ctr"/>
@@ -9607,7 +9631,9 @@
           </a:fontRef>
         </p:style>
         <p:txBody>
-          <a:bodyPr rtlCol="0" anchor="ctr" wrap="square"/>
+          <a:bodyPr rtlCol="0" anchor="ctr" wrap="square">
+            <a:normAutofit/>
+          </a:bodyPr>
           <a:lstStyle/>
           <a:p>
             <a:pPr algn="ctr"/>
@@ -9631,8 +9657,8 @@
         </p:nvCxnSpPr>
         <p:spPr>
           <a:xfrm>
-            <a:off x="1828800" y="1664208"/>
-            <a:ext cx="0" cy="438912"/>
+            <a:off x="1828800" y="1938528"/>
+            <a:ext cx="0" cy="146303"/>
           </a:xfrm>
           <a:prstGeom prst="line">
             <a:avLst/>
@@ -9667,8 +9693,8 @@
         </p:nvCxnSpPr>
         <p:spPr>
           <a:xfrm>
-            <a:off x="1828800" y="1664208"/>
-            <a:ext cx="0" cy="1261872"/>
+            <a:off x="1828800" y="2761488"/>
+            <a:ext cx="0" cy="146304"/>
           </a:xfrm>
           <a:prstGeom prst="line">
             <a:avLst/>
@@ -9703,8 +9729,8 @@
         </p:nvCxnSpPr>
         <p:spPr>
           <a:xfrm>
-            <a:off x="1828800" y="1664208"/>
-            <a:ext cx="0" cy="2176272"/>
+            <a:off x="1828800" y="3675887"/>
+            <a:ext cx="0" cy="146304"/>
           </a:xfrm>
           <a:prstGeom prst="line">
             <a:avLst/>
@@ -9739,8 +9765,8 @@
         </p:nvCxnSpPr>
         <p:spPr>
           <a:xfrm>
-            <a:off x="1828800" y="1664208"/>
-            <a:ext cx="0" cy="3090672"/>
+            <a:off x="1828800" y="4590288"/>
+            <a:ext cx="0" cy="146304"/>
           </a:xfrm>
           <a:prstGeom prst="line">
             <a:avLst/>
@@ -9775,8 +9801,8 @@
         </p:nvCxnSpPr>
         <p:spPr>
           <a:xfrm>
-            <a:off x="2834640" y="5166360"/>
-            <a:ext cx="530352" cy="0"/>
+            <a:off x="1828800" y="5596128"/>
+            <a:ext cx="0" cy="146304"/>
           </a:xfrm>
           <a:prstGeom prst="line">
             <a:avLst/>
@@ -9811,8 +9837,8 @@
         </p:nvCxnSpPr>
         <p:spPr>
           <a:xfrm>
-            <a:off x="1828800" y="5577840"/>
-            <a:ext cx="0" cy="164592"/>
+            <a:off x="2852928" y="5166360"/>
+            <a:ext cx="512064" cy="0"/>
           </a:xfrm>
           <a:prstGeom prst="line">
             <a:avLst/>
@@ -10228,7 +10254,9 @@
           </a:fontRef>
         </p:style>
         <p:txBody>
-          <a:bodyPr rtlCol="0" anchor="ctr" wrap="square"/>
+          <a:bodyPr rtlCol="0" anchor="ctr" wrap="square">
+            <a:normAutofit/>
+          </a:bodyPr>
           <a:lstStyle/>
           <a:p>
             <a:pPr algn="ctr"/>
@@ -10282,7 +10310,9 @@
           </a:fontRef>
         </p:style>
         <p:txBody>
-          <a:bodyPr rtlCol="0" anchor="ctr" wrap="square"/>
+          <a:bodyPr rtlCol="0" anchor="ctr" wrap="square">
+            <a:normAutofit/>
+          </a:bodyPr>
           <a:lstStyle/>
           <a:p>
             <a:pPr algn="ctr"/>
@@ -10336,7 +10366,9 @@
           </a:fontRef>
         </p:style>
         <p:txBody>
-          <a:bodyPr rtlCol="0" anchor="ctr" wrap="square"/>
+          <a:bodyPr rtlCol="0" anchor="ctr" wrap="square">
+            <a:normAutofit/>
+          </a:bodyPr>
           <a:lstStyle/>
           <a:p>
             <a:pPr algn="ctr"/>
@@ -10390,7 +10422,9 @@
           </a:fontRef>
         </p:style>
         <p:txBody>
-          <a:bodyPr rtlCol="0" anchor="ctr" wrap="square"/>
+          <a:bodyPr rtlCol="0" anchor="ctr" wrap="square">
+            <a:normAutofit/>
+          </a:bodyPr>
           <a:lstStyle/>
           <a:p>
             <a:pPr algn="ctr"/>
@@ -10444,7 +10478,9 @@
           </a:fontRef>
         </p:style>
         <p:txBody>
-          <a:bodyPr rtlCol="0" anchor="ctr" wrap="square"/>
+          <a:bodyPr rtlCol="0" anchor="ctr" wrap="square">
+            <a:normAutofit/>
+          </a:bodyPr>
           <a:lstStyle/>
           <a:p>
             <a:pPr algn="ctr"/>
@@ -10648,7 +10684,7 @@
         <p:spPr>
           <a:xfrm>
             <a:off x="640080" y="4434840"/>
-            <a:ext cx="1325880" cy="1051560"/>
+            <a:ext cx="1554480" cy="914400"/>
           </a:xfrm>
           <a:prstGeom prst="roundRect">
             <a:avLst>
@@ -10679,12 +10715,14 @@
           </a:fontRef>
         </p:style>
         <p:txBody>
-          <a:bodyPr rtlCol="0" anchor="ctr" wrap="square"/>
+          <a:bodyPr rtlCol="0" anchor="ctr" wrap="square">
+            <a:normAutofit/>
+          </a:bodyPr>
           <a:lstStyle/>
           <a:p>
             <a:pPr algn="ctr"/>
             <a:r>
-              <a:rPr sz="1050" b="0" i="0">
+              <a:rPr sz="1100" b="0" i="0">
                 <a:solidFill>
                   <a:srgbClr val="1F2937"/>
                 </a:solidFill>
@@ -10704,8 +10742,8 @@
         </p:nvSpPr>
         <p:spPr>
           <a:xfrm>
-            <a:off x="2148840" y="4434840"/>
-            <a:ext cx="1325880" cy="1051560"/>
+            <a:off x="2404872" y="4434840"/>
+            <a:ext cx="1554480" cy="914400"/>
           </a:xfrm>
           <a:prstGeom prst="roundRect">
             <a:avLst>
@@ -10736,12 +10774,14 @@
           </a:fontRef>
         </p:style>
         <p:txBody>
-          <a:bodyPr rtlCol="0" anchor="ctr" wrap="square"/>
+          <a:bodyPr rtlCol="0" anchor="ctr" wrap="square">
+            <a:normAutofit/>
+          </a:bodyPr>
           <a:lstStyle/>
           <a:p>
             <a:pPr algn="ctr"/>
             <a:r>
-              <a:rPr sz="1050" b="0" i="0">
+              <a:rPr sz="1100" b="0" i="0">
                 <a:solidFill>
                   <a:srgbClr val="1F2937"/>
                 </a:solidFill>
@@ -10761,8 +10801,8 @@
         </p:nvCxnSpPr>
         <p:spPr>
           <a:xfrm>
-            <a:off x="1892808" y="4956048"/>
-            <a:ext cx="274320" cy="0"/>
+            <a:off x="2212848" y="4892040"/>
+            <a:ext cx="201167" cy="0"/>
           </a:xfrm>
           <a:prstGeom prst="line">
             <a:avLst/>
@@ -10797,8 +10837,8 @@
         </p:nvSpPr>
         <p:spPr>
           <a:xfrm>
-            <a:off x="3520440" y="4434840"/>
-            <a:ext cx="1325880" cy="1051560"/>
+            <a:off x="4169663" y="4434840"/>
+            <a:ext cx="1554480" cy="914400"/>
           </a:xfrm>
           <a:prstGeom prst="roundRect">
             <a:avLst>
@@ -10829,12 +10869,14 @@
           </a:fontRef>
         </p:style>
         <p:txBody>
-          <a:bodyPr rtlCol="0" anchor="ctr" wrap="square"/>
+          <a:bodyPr rtlCol="0" anchor="ctr" wrap="square">
+            <a:normAutofit/>
+          </a:bodyPr>
           <a:lstStyle/>
           <a:p>
             <a:pPr algn="ctr"/>
             <a:r>
-              <a:rPr sz="1050" b="0" i="0">
+              <a:rPr sz="1100" b="0" i="0">
                 <a:solidFill>
                   <a:srgbClr val="1F2937"/>
                 </a:solidFill>
@@ -10854,8 +10896,8 @@
         </p:nvCxnSpPr>
         <p:spPr>
           <a:xfrm>
-            <a:off x="3264408" y="4956048"/>
-            <a:ext cx="274320" cy="0"/>
+            <a:off x="3977639" y="4892040"/>
+            <a:ext cx="201168" cy="0"/>
           </a:xfrm>
           <a:prstGeom prst="line">
             <a:avLst/>
@@ -10890,8 +10932,8 @@
         </p:nvSpPr>
         <p:spPr>
           <a:xfrm>
-            <a:off x="4892040" y="4434840"/>
-            <a:ext cx="1325880" cy="1051560"/>
+            <a:off x="5934456" y="4434840"/>
+            <a:ext cx="1554480" cy="914400"/>
           </a:xfrm>
           <a:prstGeom prst="roundRect">
             <a:avLst>
@@ -10922,19 +10964,21 @@
           </a:fontRef>
         </p:style>
         <p:txBody>
-          <a:bodyPr rtlCol="0" anchor="ctr" wrap="square"/>
+          <a:bodyPr rtlCol="0" anchor="ctr" wrap="square">
+            <a:normAutofit/>
+          </a:bodyPr>
           <a:lstStyle/>
           <a:p>
             <a:pPr algn="ctr"/>
             <a:r>
-              <a:rPr sz="1050" b="0" i="0">
+              <a:rPr sz="1100" b="0" i="0">
                 <a:solidFill>
                   <a:srgbClr val="1F2937"/>
                 </a:solidFill>
                 <a:latin typeface="Calibri"/>
               </a:rPr>
-              <a:t>Frame Area
-H × W</a:t>
+              <a:t>Ds =
+Defect / Frame</a:t>
             </a:r>
           </a:p>
         </p:txBody>
@@ -10947,8 +10991,8 @@
         </p:nvCxnSpPr>
         <p:spPr>
           <a:xfrm>
-            <a:off x="4636007" y="4956048"/>
-            <a:ext cx="274320" cy="0"/>
+            <a:off x="5742432" y="4892040"/>
+            <a:ext cx="201168" cy="0"/>
           </a:xfrm>
           <a:prstGeom prst="line">
             <a:avLst/>
@@ -10983,8 +11027,8 @@
         </p:nvSpPr>
         <p:spPr>
           <a:xfrm>
-            <a:off x="6355080" y="4434840"/>
-            <a:ext cx="1325880" cy="1051560"/>
+            <a:off x="7699248" y="4434840"/>
+            <a:ext cx="1554480" cy="914400"/>
           </a:xfrm>
           <a:prstGeom prst="roundRect">
             <a:avLst>
@@ -11015,33 +11059,71 @@
           </a:fontRef>
         </p:style>
         <p:txBody>
-          <a:bodyPr rtlCol="0" anchor="ctr" wrap="square"/>
+          <a:bodyPr rtlCol="0" anchor="ctr" wrap="square">
+            <a:normAutofit/>
+          </a:bodyPr>
           <a:lstStyle/>
           <a:p>
             <a:pPr algn="ctr"/>
             <a:r>
-              <a:rPr sz="1050" b="0" i="0">
+              <a:rPr sz="1100" b="0" i="0">
                 <a:solidFill>
                   <a:srgbClr val="1F2937"/>
                 </a:solidFill>
                 <a:latin typeface="Calibri"/>
               </a:rPr>
-              <a:t>Ds =
-Defect / Frame</a:t>
-            </a:r>
-          </a:p>
-        </p:txBody>
-      </p:sp>
-      <p:sp>
-        <p:nvSpPr>
-          <p:cNvPr id="26" name="Rounded Rectangle 25"/>
+              <a:t>Rolling Avg.
+Last 10 Frames</a:t>
+            </a:r>
+          </a:p>
+        </p:txBody>
+      </p:sp>
+      <p:cxnSp>
+        <p:nvCxnSpPr>
+          <p:cNvPr id="26" name="Connector 25"/>
+          <p:cNvCxnSpPr/>
+          <p:nvPr/>
+        </p:nvCxnSpPr>
+        <p:spPr>
+          <a:xfrm>
+            <a:off x="7507223" y="4892040"/>
+            <a:ext cx="201169" cy="0"/>
+          </a:xfrm>
+          <a:prstGeom prst="line">
+            <a:avLst/>
+          </a:prstGeom>
+          <a:ln w="19050">
+            <a:solidFill>
+              <a:srgbClr val="1F2937"/>
+            </a:solidFill>
+            <a:tailEnd type="triangle" w="med" len="med"/>
+          </a:ln>
+        </p:spPr>
+        <p:style>
+          <a:lnRef idx="2">
+            <a:schemeClr val="accent1"/>
+          </a:lnRef>
+          <a:fillRef idx="0">
+            <a:schemeClr val="accent1"/>
+          </a:fillRef>
+          <a:effectRef idx="1">
+            <a:schemeClr val="accent1"/>
+          </a:effectRef>
+          <a:fontRef idx="minor">
+            <a:schemeClr val="tx1"/>
+          </a:fontRef>
+        </p:style>
+      </p:cxnSp>
+      <p:sp>
+        <p:nvSpPr>
+          <p:cNvPr id="27" name="Rounded Rectangle 26"/>
           <p:cNvSpPr/>
           <p:nvPr/>
         </p:nvSpPr>
         <p:spPr>
           <a:xfrm>
-            <a:off x="7818120" y="4434840"/>
-            <a:ext cx="1325880" cy="1051560"/>
+            <a:off x="9464040" y="4434840"/>
+            <a:ext cx="1554480" cy="914400"/>
           </a:xfrm>
           <a:prstGeom prst="roundRect">
             <a:avLst>
@@ -11072,33 +11154,35 @@
           </a:fontRef>
         </p:style>
         <p:txBody>
-          <a:bodyPr rtlCol="0" anchor="ctr" wrap="square"/>
+          <a:bodyPr rtlCol="0" anchor="ctr" wrap="square">
+            <a:normAutofit/>
+          </a:bodyPr>
           <a:lstStyle/>
           <a:p>
             <a:pPr algn="ctr"/>
             <a:r>
-              <a:rPr sz="1050" b="0" i="0">
+              <a:rPr sz="1100" b="0" i="0">
                 <a:solidFill>
                   <a:srgbClr val="1F2937"/>
                 </a:solidFill>
                 <a:latin typeface="Calibri"/>
               </a:rPr>
-              <a:t>Rolling Avg.
-Last 10 Frames</a:t>
+              <a:t>Predictor
+Input</a:t>
             </a:r>
           </a:p>
         </p:txBody>
       </p:sp>
       <p:cxnSp>
         <p:nvCxnSpPr>
-          <p:cNvPr id="27" name="Connector 26"/>
+          <p:cNvPr id="28" name="Connector 27"/>
           <p:cNvCxnSpPr/>
           <p:nvPr/>
         </p:nvCxnSpPr>
         <p:spPr>
           <a:xfrm>
-            <a:off x="7562088" y="4956048"/>
-            <a:ext cx="274320" cy="0"/>
+            <a:off x="9272015" y="4892040"/>
+            <a:ext cx="201169" cy="0"/>
           </a:xfrm>
           <a:prstGeom prst="line">
             <a:avLst/>
@@ -11127,14 +11211,14 @@
       </p:cxnSp>
       <p:sp>
         <p:nvSpPr>
-          <p:cNvPr id="28" name="Rounded Rectangle 27"/>
+          <p:cNvPr id="29" name="Rounded Rectangle 28"/>
           <p:cNvSpPr/>
           <p:nvPr/>
         </p:nvSpPr>
         <p:spPr>
           <a:xfrm>
-            <a:off x="9464040" y="4434840"/>
-            <a:ext cx="1325880" cy="1051560"/>
+            <a:off x="5934456" y="5486400"/>
+            <a:ext cx="1554480" cy="658368"/>
           </a:xfrm>
           <a:prstGeom prst="roundRect">
             <a:avLst>
@@ -11165,59 +11249,25 @@
           </a:fontRef>
         </p:style>
         <p:txBody>
-          <a:bodyPr rtlCol="0" anchor="ctr" wrap="square"/>
+          <a:bodyPr rtlCol="0" anchor="ctr" wrap="square">
+            <a:normAutofit/>
+          </a:bodyPr>
           <a:lstStyle/>
           <a:p>
             <a:pPr algn="ctr"/>
             <a:r>
-              <a:rPr sz="1050" b="0" i="0">
+              <a:rPr sz="1100" b="0" i="0">
                 <a:solidFill>
                   <a:srgbClr val="1F2937"/>
                 </a:solidFill>
                 <a:latin typeface="Calibri"/>
               </a:rPr>
-              <a:t>Predictor
-Input</a:t>
-            </a:r>
-          </a:p>
-        </p:txBody>
-      </p:sp>
-      <p:cxnSp>
-        <p:nvCxnSpPr>
-          <p:cNvPr id="29" name="Connector 28"/>
-          <p:cNvCxnSpPr/>
-          <p:nvPr/>
-        </p:nvCxnSpPr>
-        <p:spPr>
-          <a:xfrm>
-            <a:off x="9208008" y="4956048"/>
-            <a:ext cx="274320" cy="0"/>
-          </a:xfrm>
-          <a:prstGeom prst="line">
-            <a:avLst/>
-          </a:prstGeom>
-          <a:ln w="19050">
-            <a:solidFill>
-              <a:srgbClr val="1F2937"/>
-            </a:solidFill>
-            <a:tailEnd type="triangle" w="med" len="med"/>
-          </a:ln>
-        </p:spPr>
-        <p:style>
-          <a:lnRef idx="2">
-            <a:schemeClr val="accent1"/>
-          </a:lnRef>
-          <a:fillRef idx="0">
-            <a:schemeClr val="accent1"/>
-          </a:fillRef>
-          <a:effectRef idx="1">
-            <a:schemeClr val="accent1"/>
-          </a:effectRef>
-          <a:fontRef idx="minor">
-            <a:schemeClr val="tx1"/>
-          </a:fontRef>
-        </p:style>
-      </p:cxnSp>
+              <a:t>Frame Area
+H × W</a:t>
+            </a:r>
+          </a:p>
+        </p:txBody>
+      </p:sp>
       <p:cxnSp>
         <p:nvCxnSpPr>
           <p:cNvPr id="30" name="Connector 29"/>
@@ -11225,45 +11275,9 @@
           <p:nvPr/>
         </p:nvCxnSpPr>
         <p:spPr>
-          <a:xfrm>
-            <a:off x="4846320" y="4754880"/>
-            <a:ext cx="1280160" cy="0"/>
-          </a:xfrm>
-          <a:prstGeom prst="line">
-            <a:avLst/>
-          </a:prstGeom>
-          <a:ln w="19050">
-            <a:solidFill>
-              <a:srgbClr val="1F2937"/>
-            </a:solidFill>
-            <a:tailEnd type="triangle" w="med" len="med"/>
-          </a:ln>
-        </p:spPr>
-        <p:style>
-          <a:lnRef idx="2">
-            <a:schemeClr val="accent1"/>
-          </a:lnRef>
-          <a:fillRef idx="0">
-            <a:schemeClr val="accent1"/>
-          </a:fillRef>
-          <a:effectRef idx="1">
-            <a:schemeClr val="accent1"/>
-          </a:effectRef>
-          <a:fontRef idx="minor">
-            <a:schemeClr val="tx1"/>
-          </a:fontRef>
-        </p:style>
-      </p:cxnSp>
-      <p:cxnSp>
-        <p:nvCxnSpPr>
-          <p:cNvPr id="31" name="Connector 30"/>
-          <p:cNvCxnSpPr/>
-          <p:nvPr/>
-        </p:nvCxnSpPr>
-        <p:spPr>
           <a:xfrm flipV="1">
-            <a:off x="5532120" y="5166360"/>
-            <a:ext cx="594360" cy="182880"/>
+            <a:off x="6711696" y="5367528"/>
+            <a:ext cx="0" cy="100584"/>
           </a:xfrm>
           <a:prstGeom prst="line">
             <a:avLst/>
@@ -11547,7 +11561,9 @@
           </a:fontRef>
         </p:style>
         <p:txBody>
-          <a:bodyPr rtlCol="0" anchor="ctr" wrap="square"/>
+          <a:bodyPr rtlCol="0" anchor="ctr" wrap="square">
+            <a:normAutofit/>
+          </a:bodyPr>
           <a:lstStyle/>
           <a:p>
             <a:pPr algn="ctr"/>
@@ -11604,7 +11620,9 @@
           </a:fontRef>
         </p:style>
         <p:txBody>
-          <a:bodyPr rtlCol="0" anchor="ctr" wrap="square"/>
+          <a:bodyPr rtlCol="0" anchor="ctr" wrap="square">
+            <a:normAutofit/>
+          </a:bodyPr>
           <a:lstStyle/>
           <a:p>
             <a:pPr algn="ctr"/>
@@ -11661,7 +11679,9 @@
           </a:fontRef>
         </p:style>
         <p:txBody>
-          <a:bodyPr rtlCol="0" anchor="ctr" wrap="square"/>
+          <a:bodyPr rtlCol="0" anchor="ctr" wrap="square">
+            <a:normAutofit/>
+          </a:bodyPr>
           <a:lstStyle/>
           <a:p>
             <a:pPr algn="ctr"/>
@@ -11718,7 +11738,9 @@
           </a:fontRef>
         </p:style>
         <p:txBody>
-          <a:bodyPr rtlCol="0" anchor="ctr" wrap="square"/>
+          <a:bodyPr rtlCol="0" anchor="ctr" wrap="square">
+            <a:normAutofit/>
+          </a:bodyPr>
           <a:lstStyle/>
           <a:p>
             <a:pPr algn="ctr"/>
@@ -11775,7 +11797,9 @@
           </a:fontRef>
         </p:style>
         <p:txBody>
-          <a:bodyPr rtlCol="0" anchor="ctr" wrap="square"/>
+          <a:bodyPr rtlCol="0" anchor="ctr" wrap="square">
+            <a:normAutofit/>
+          </a:bodyPr>
           <a:lstStyle/>
           <a:p>
             <a:pPr algn="ctr"/>
@@ -11832,7 +11856,9 @@
           </a:fontRef>
         </p:style>
         <p:txBody>
-          <a:bodyPr rtlCol="0" anchor="ctr" wrap="square"/>
+          <a:bodyPr rtlCol="0" anchor="ctr" wrap="square">
+            <a:normAutofit/>
+          </a:bodyPr>
           <a:lstStyle/>
           <a:p>
             <a:pPr algn="ctr"/>
@@ -12341,8 +12367,8 @@
         </p:nvSpPr>
         <p:spPr>
           <a:xfrm>
-            <a:off x="914400" y="1463040"/>
-            <a:ext cx="2194560" cy="685800"/>
+            <a:off x="4480560" y="1463040"/>
+            <a:ext cx="3200400" cy="640080"/>
           </a:xfrm>
           <a:prstGeom prst="roundRect">
             <a:avLst>
@@ -12373,33 +12399,70 @@
           </a:fontRef>
         </p:style>
         <p:txBody>
-          <a:bodyPr rtlCol="0" anchor="ctr" wrap="square"/>
+          <a:bodyPr rtlCol="0" anchor="ctr" wrap="square">
+            <a:normAutofit/>
+          </a:bodyPr>
           <a:lstStyle/>
           <a:p>
             <a:pPr algn="ctr"/>
             <a:r>
-              <a:rPr sz="1150" b="0" i="0">
+              <a:rPr sz="1200" b="0" i="0">
                 <a:solidFill>
                   <a:srgbClr val="1F2937"/>
                 </a:solidFill>
                 <a:latin typeface="Calibri"/>
               </a:rPr>
-              <a:t>Calibrate Pixels
-To Inches (Fixed Geometry)</a:t>
-            </a:r>
-          </a:p>
-        </p:txBody>
-      </p:sp>
-      <p:sp>
-        <p:nvSpPr>
-          <p:cNvPr id="8" name="Rounded Rectangle 7"/>
+              <a:t>Calibrate Pixels To Inches (Fixed Geometry)</a:t>
+            </a:r>
+          </a:p>
+        </p:txBody>
+      </p:sp>
+      <p:cxnSp>
+        <p:nvCxnSpPr>
+          <p:cNvPr id="8" name="Connector 7"/>
+          <p:cNvCxnSpPr/>
+          <p:nvPr/>
+        </p:nvCxnSpPr>
+        <p:spPr>
+          <a:xfrm>
+            <a:off x="6080760" y="2121408"/>
+            <a:ext cx="0" cy="146304"/>
+          </a:xfrm>
+          <a:prstGeom prst="line">
+            <a:avLst/>
+          </a:prstGeom>
+          <a:ln w="19050">
+            <a:solidFill>
+              <a:srgbClr val="1F2937"/>
+            </a:solidFill>
+            <a:tailEnd type="triangle" w="med" len="med"/>
+          </a:ln>
+        </p:spPr>
+        <p:style>
+          <a:lnRef idx="2">
+            <a:schemeClr val="accent1"/>
+          </a:lnRef>
+          <a:fillRef idx="0">
+            <a:schemeClr val="accent1"/>
+          </a:fillRef>
+          <a:effectRef idx="1">
+            <a:schemeClr val="accent1"/>
+          </a:effectRef>
+          <a:fontRef idx="minor">
+            <a:schemeClr val="tx1"/>
+          </a:fontRef>
+        </p:style>
+      </p:cxnSp>
+      <p:sp>
+        <p:nvSpPr>
+          <p:cNvPr id="9" name="Rounded Rectangle 8"/>
           <p:cNvSpPr/>
           <p:nvPr/>
         </p:nvSpPr>
         <p:spPr>
           <a:xfrm>
-            <a:off x="914400" y="2331720"/>
-            <a:ext cx="2194560" cy="640080"/>
+            <a:off x="4480560" y="2286000"/>
+            <a:ext cx="3200400" cy="640080"/>
           </a:xfrm>
           <a:prstGeom prst="roundRect">
             <a:avLst>
@@ -12430,33 +12493,70 @@
           </a:fontRef>
         </p:style>
         <p:txBody>
-          <a:bodyPr rtlCol="0" anchor="ctr" wrap="square"/>
+          <a:bodyPr rtlCol="0" anchor="ctr" wrap="square">
+            <a:normAutofit/>
+          </a:bodyPr>
           <a:lstStyle/>
           <a:p>
             <a:pPr algn="ctr"/>
             <a:r>
-              <a:rPr sz="1150" b="0" i="0">
+              <a:rPr sz="1200" b="0" i="0">
                 <a:solidFill>
                   <a:srgbClr val="1F2937"/>
                 </a:solidFill>
                 <a:latin typeface="Calibri"/>
               </a:rPr>
-              <a:t>Measure Fault
-Length</a:t>
-            </a:r>
-          </a:p>
-        </p:txBody>
-      </p:sp>
-      <p:sp>
-        <p:nvSpPr>
-          <p:cNvPr id="9" name="Diamond 8"/>
+              <a:t>Measure Fault Length</a:t>
+            </a:r>
+          </a:p>
+        </p:txBody>
+      </p:sp>
+      <p:cxnSp>
+        <p:nvCxnSpPr>
+          <p:cNvPr id="10" name="Connector 9"/>
+          <p:cNvCxnSpPr/>
+          <p:nvPr/>
+        </p:nvCxnSpPr>
+        <p:spPr>
+          <a:xfrm>
+            <a:off x="6080760" y="2944368"/>
+            <a:ext cx="0" cy="146304"/>
+          </a:xfrm>
+          <a:prstGeom prst="line">
+            <a:avLst/>
+          </a:prstGeom>
+          <a:ln w="19050">
+            <a:solidFill>
+              <a:srgbClr val="1F2937"/>
+            </a:solidFill>
+            <a:tailEnd type="triangle" w="med" len="med"/>
+          </a:ln>
+        </p:spPr>
+        <p:style>
+          <a:lnRef idx="2">
+            <a:schemeClr val="accent1"/>
+          </a:lnRef>
+          <a:fillRef idx="0">
+            <a:schemeClr val="accent1"/>
+          </a:fillRef>
+          <a:effectRef idx="1">
+            <a:schemeClr val="accent1"/>
+          </a:effectRef>
+          <a:fontRef idx="minor">
+            <a:schemeClr val="tx1"/>
+          </a:fontRef>
+        </p:style>
+      </p:cxnSp>
+      <p:sp>
+        <p:nvSpPr>
+          <p:cNvPr id="11" name="Diamond 10"/>
           <p:cNvSpPr/>
           <p:nvPr/>
         </p:nvSpPr>
         <p:spPr>
           <a:xfrm>
-            <a:off x="914400" y="3154680"/>
-            <a:ext cx="2194560" cy="822960"/>
+            <a:off x="5349240" y="3108960"/>
+            <a:ext cx="1463040" cy="914400"/>
           </a:xfrm>
           <a:prstGeom prst="diamond">
             <a:avLst/>
@@ -12485,7 +12585,9 @@
           </a:fontRef>
         </p:style>
         <p:txBody>
-          <a:bodyPr rtlCol="0" anchor="ctr" wrap="square"/>
+          <a:bodyPr rtlCol="0" anchor="ctr" wrap="square">
+            <a:normAutofit/>
+          </a:bodyPr>
           <a:lstStyle/>
           <a:p>
             <a:pPr algn="ctr"/>
@@ -12503,14 +12605,14 @@
       </p:sp>
       <p:sp>
         <p:nvSpPr>
-          <p:cNvPr id="10" name="Rounded Rectangle 9"/>
+          <p:cNvPr id="12" name="Rounded Rectangle 11"/>
           <p:cNvSpPr/>
           <p:nvPr/>
         </p:nvSpPr>
         <p:spPr>
           <a:xfrm>
-            <a:off x="3657600" y="3154680"/>
-            <a:ext cx="1828800" cy="822960"/>
+            <a:off x="640080" y="4480560"/>
+            <a:ext cx="2560320" cy="777240"/>
           </a:xfrm>
           <a:prstGeom prst="roundRect">
             <a:avLst>
@@ -12541,12 +12643,14 @@
           </a:fontRef>
         </p:style>
         <p:txBody>
-          <a:bodyPr rtlCol="0" anchor="ctr" wrap="square"/>
+          <a:bodyPr rtlCol="0" anchor="ctr" wrap="square">
+            <a:normAutofit/>
+          </a:bodyPr>
           <a:lstStyle/>
           <a:p>
             <a:pPr algn="ctr"/>
             <a:r>
-              <a:rPr sz="1100" b="0" i="0">
+              <a:rPr sz="1150" b="0" i="0">
                 <a:solidFill>
                   <a:srgbClr val="1F2937"/>
                 </a:solidFill>
@@ -12560,14 +12664,14 @@
       </p:sp>
       <p:cxnSp>
         <p:nvCxnSpPr>
-          <p:cNvPr id="11" name="Connector 10"/>
+          <p:cNvPr id="13" name="Connector 12"/>
           <p:cNvCxnSpPr/>
           <p:nvPr/>
         </p:nvCxnSpPr>
         <p:spPr>
-          <a:xfrm flipV="1">
-            <a:off x="2011680" y="3136392"/>
-            <a:ext cx="2468880" cy="612647"/>
+          <a:xfrm flipH="1">
+            <a:off x="1920239" y="4041648"/>
+            <a:ext cx="3840481" cy="420624"/>
           </a:xfrm>
           <a:prstGeom prst="line">
             <a:avLst/>
@@ -12596,14 +12700,14 @@
       </p:cxnSp>
       <p:sp>
         <p:nvSpPr>
-          <p:cNvPr id="12" name="Rounded Rectangle 11"/>
+          <p:cNvPr id="14" name="Rounded Rectangle 13"/>
           <p:cNvSpPr/>
           <p:nvPr/>
         </p:nvSpPr>
         <p:spPr>
           <a:xfrm>
-            <a:off x="5715000" y="3154680"/>
-            <a:ext cx="1828800" cy="822960"/>
+            <a:off x="3410712" y="4480560"/>
+            <a:ext cx="2560320" cy="777240"/>
           </a:xfrm>
           <a:prstGeom prst="roundRect">
             <a:avLst>
@@ -12634,12 +12738,14 @@
           </a:fontRef>
         </p:style>
         <p:txBody>
-          <a:bodyPr rtlCol="0" anchor="ctr" wrap="square"/>
+          <a:bodyPr rtlCol="0" anchor="ctr" wrap="square">
+            <a:normAutofit/>
+          </a:bodyPr>
           <a:lstStyle/>
           <a:p>
             <a:pPr algn="ctr"/>
             <a:r>
-              <a:rPr sz="1100" b="0" i="0">
+              <a:rPr sz="1150" b="0" i="0">
                 <a:solidFill>
                   <a:srgbClr val="1F2937"/>
                 </a:solidFill>
@@ -12653,14 +12759,14 @@
       </p:sp>
       <p:cxnSp>
         <p:nvCxnSpPr>
-          <p:cNvPr id="13" name="Connector 12"/>
+          <p:cNvPr id="15" name="Connector 14"/>
           <p:cNvCxnSpPr/>
           <p:nvPr/>
         </p:nvCxnSpPr>
         <p:spPr>
-          <a:xfrm flipV="1">
-            <a:off x="2011680" y="3136392"/>
-            <a:ext cx="4526280" cy="612647"/>
+          <a:xfrm flipH="1">
+            <a:off x="4690872" y="4041648"/>
+            <a:ext cx="1298448" cy="420624"/>
           </a:xfrm>
           <a:prstGeom prst="line">
             <a:avLst/>
@@ -12689,14 +12795,14 @@
       </p:cxnSp>
       <p:sp>
         <p:nvSpPr>
-          <p:cNvPr id="14" name="Rounded Rectangle 13"/>
+          <p:cNvPr id="16" name="Rounded Rectangle 15"/>
           <p:cNvSpPr/>
           <p:nvPr/>
         </p:nvSpPr>
         <p:spPr>
           <a:xfrm>
-            <a:off x="7772400" y="3154680"/>
-            <a:ext cx="1828800" cy="822960"/>
+            <a:off x="6181344" y="4480560"/>
+            <a:ext cx="2560320" cy="777240"/>
           </a:xfrm>
           <a:prstGeom prst="roundRect">
             <a:avLst>
@@ -12727,12 +12833,14 @@
           </a:fontRef>
         </p:style>
         <p:txBody>
-          <a:bodyPr rtlCol="0" anchor="ctr" wrap="square"/>
+          <a:bodyPr rtlCol="0" anchor="ctr" wrap="square">
+            <a:normAutofit/>
+          </a:bodyPr>
           <a:lstStyle/>
           <a:p>
             <a:pPr algn="ctr"/>
             <a:r>
-              <a:rPr sz="1100" b="0" i="0">
+              <a:rPr sz="1150" b="0" i="0">
                 <a:solidFill>
                   <a:srgbClr val="1F2937"/>
                 </a:solidFill>
@@ -12746,14 +12854,14 @@
       </p:sp>
       <p:cxnSp>
         <p:nvCxnSpPr>
-          <p:cNvPr id="15" name="Connector 14"/>
+          <p:cNvPr id="17" name="Connector 16"/>
           <p:cNvCxnSpPr/>
           <p:nvPr/>
         </p:nvCxnSpPr>
         <p:spPr>
-          <a:xfrm flipV="1">
-            <a:off x="2011680" y="3136392"/>
-            <a:ext cx="6583680" cy="612647"/>
+          <a:xfrm>
+            <a:off x="6217920" y="4041648"/>
+            <a:ext cx="1243584" cy="420624"/>
           </a:xfrm>
           <a:prstGeom prst="line">
             <a:avLst/>
@@ -12782,14 +12890,14 @@
       </p:cxnSp>
       <p:sp>
         <p:nvSpPr>
-          <p:cNvPr id="16" name="Rounded Rectangle 15"/>
+          <p:cNvPr id="18" name="Rounded Rectangle 17"/>
           <p:cNvSpPr/>
           <p:nvPr/>
         </p:nvSpPr>
         <p:spPr>
           <a:xfrm>
-            <a:off x="9829800" y="3154680"/>
-            <a:ext cx="1828800" cy="822960"/>
+            <a:off x="8951976" y="4480560"/>
+            <a:ext cx="2560320" cy="777240"/>
           </a:xfrm>
           <a:prstGeom prst="roundRect">
             <a:avLst>
@@ -12820,12 +12928,14 @@
           </a:fontRef>
         </p:style>
         <p:txBody>
-          <a:bodyPr rtlCol="0" anchor="ctr" wrap="square"/>
+          <a:bodyPr rtlCol="0" anchor="ctr" wrap="square">
+            <a:normAutofit/>
+          </a:bodyPr>
           <a:lstStyle/>
           <a:p>
             <a:pPr algn="ctr"/>
             <a:r>
-              <a:rPr sz="1100" b="0" i="0">
+              <a:rPr sz="1150" b="0" i="0">
                 <a:solidFill>
                   <a:srgbClr val="1F2937"/>
                 </a:solidFill>
@@ -12840,14 +12950,14 @@
       </p:sp>
       <p:cxnSp>
         <p:nvCxnSpPr>
-          <p:cNvPr id="17" name="Connector 16"/>
+          <p:cNvPr id="19" name="Connector 18"/>
           <p:cNvCxnSpPr/>
           <p:nvPr/>
         </p:nvCxnSpPr>
         <p:spPr>
-          <a:xfrm flipV="1">
-            <a:off x="2011680" y="3136392"/>
-            <a:ext cx="8641080" cy="612647"/>
+          <a:xfrm>
+            <a:off x="6446520" y="4041648"/>
+            <a:ext cx="3785616" cy="420624"/>
           </a:xfrm>
           <a:prstGeom prst="line">
             <a:avLst/>
@@ -12876,14 +12986,14 @@
       </p:cxnSp>
       <p:sp>
         <p:nvSpPr>
-          <p:cNvPr id="18" name="Rounded Rectangle 17"/>
+          <p:cNvPr id="20" name="Rounded Rectangle 19"/>
           <p:cNvSpPr/>
           <p:nvPr/>
         </p:nvSpPr>
         <p:spPr>
           <a:xfrm>
-            <a:off x="1463040" y="4297680"/>
-            <a:ext cx="2926080" cy="731520"/>
+            <a:off x="4800600" y="5440680"/>
+            <a:ext cx="2560320" cy="731520"/>
           </a:xfrm>
           <a:prstGeom prst="roundRect">
             <a:avLst>
@@ -12914,7 +13024,9 @@
           </a:fontRef>
         </p:style>
         <p:txBody>
-          <a:bodyPr rtlCol="0" anchor="ctr" wrap="square"/>
+          <a:bodyPr rtlCol="0" anchor="ctr" wrap="square">
+            <a:normAutofit/>
+          </a:bodyPr>
           <a:lstStyle/>
           <a:p>
             <a:pPr algn="ctr"/>
@@ -12930,78 +13042,6 @@
           </a:p>
         </p:txBody>
       </p:sp>
-      <p:cxnSp>
-        <p:nvCxnSpPr>
-          <p:cNvPr id="19" name="Connector 18"/>
-          <p:cNvCxnSpPr/>
-          <p:nvPr/>
-        </p:nvCxnSpPr>
-        <p:spPr>
-          <a:xfrm>
-            <a:off x="4572000" y="3977639"/>
-            <a:ext cx="0" cy="301753"/>
-          </a:xfrm>
-          <a:prstGeom prst="line">
-            <a:avLst/>
-          </a:prstGeom>
-          <a:ln w="19050">
-            <a:solidFill>
-              <a:srgbClr val="1F2937"/>
-            </a:solidFill>
-            <a:tailEnd type="triangle" w="med" len="med"/>
-          </a:ln>
-        </p:spPr>
-        <p:style>
-          <a:lnRef idx="2">
-            <a:schemeClr val="accent1"/>
-          </a:lnRef>
-          <a:fillRef idx="0">
-            <a:schemeClr val="accent1"/>
-          </a:fillRef>
-          <a:effectRef idx="1">
-            <a:schemeClr val="accent1"/>
-          </a:effectRef>
-          <a:fontRef idx="minor">
-            <a:schemeClr val="tx1"/>
-          </a:fontRef>
-        </p:style>
-      </p:cxnSp>
-      <p:cxnSp>
-        <p:nvCxnSpPr>
-          <p:cNvPr id="20" name="Connector 19"/>
-          <p:cNvCxnSpPr/>
-          <p:nvPr/>
-        </p:nvCxnSpPr>
-        <p:spPr>
-          <a:xfrm flipH="1">
-            <a:off x="2926080" y="4279392"/>
-            <a:ext cx="1645920" cy="292608"/>
-          </a:xfrm>
-          <a:prstGeom prst="line">
-            <a:avLst/>
-          </a:prstGeom>
-          <a:ln w="19050">
-            <a:solidFill>
-              <a:srgbClr val="1F2937"/>
-            </a:solidFill>
-            <a:tailEnd type="triangle" w="med" len="med"/>
-          </a:ln>
-        </p:spPr>
-        <p:style>
-          <a:lnRef idx="2">
-            <a:schemeClr val="accent1"/>
-          </a:lnRef>
-          <a:fillRef idx="0">
-            <a:schemeClr val="accent1"/>
-          </a:fillRef>
-          <a:effectRef idx="1">
-            <a:schemeClr val="accent1"/>
-          </a:effectRef>
-          <a:fontRef idx="minor">
-            <a:schemeClr val="tx1"/>
-          </a:fontRef>
-        </p:style>
-      </p:cxnSp>
       <p:cxnSp>
         <p:nvCxnSpPr>
           <p:cNvPr id="21" name="Connector 20"/>
@@ -13010,8 +13050,8 @@
         </p:nvCxnSpPr>
         <p:spPr>
           <a:xfrm>
-            <a:off x="6629400" y="3977639"/>
-            <a:ext cx="0" cy="301753"/>
+            <a:off x="1920239" y="5276088"/>
+            <a:ext cx="0" cy="118872"/>
           </a:xfrm>
           <a:prstGeom prst="line">
             <a:avLst/>
@@ -13045,9 +13085,9 @@
           <p:nvPr/>
         </p:nvCxnSpPr>
         <p:spPr>
-          <a:xfrm flipH="1">
-            <a:off x="2926080" y="4279392"/>
-            <a:ext cx="3703320" cy="292608"/>
+          <a:xfrm>
+            <a:off x="4690872" y="5276088"/>
+            <a:ext cx="0" cy="118872"/>
           </a:xfrm>
           <a:prstGeom prst="line">
             <a:avLst/>
@@ -13082,8 +13122,8 @@
         </p:nvCxnSpPr>
         <p:spPr>
           <a:xfrm>
-            <a:off x="8686800" y="3977639"/>
-            <a:ext cx="0" cy="301753"/>
+            <a:off x="7461504" y="5276088"/>
+            <a:ext cx="0" cy="118872"/>
           </a:xfrm>
           <a:prstGeom prst="line">
             <a:avLst/>
@@ -13117,9 +13157,9 @@
           <p:nvPr/>
         </p:nvCxnSpPr>
         <p:spPr>
-          <a:xfrm flipH="1">
-            <a:off x="2926080" y="4279392"/>
-            <a:ext cx="5760720" cy="292608"/>
+          <a:xfrm>
+            <a:off x="10232136" y="5276088"/>
+            <a:ext cx="0" cy="118872"/>
           </a:xfrm>
           <a:prstGeom prst="line">
             <a:avLst/>
@@ -13154,8 +13194,8 @@
         </p:nvCxnSpPr>
         <p:spPr>
           <a:xfrm>
-            <a:off x="10744200" y="3977639"/>
-            <a:ext cx="0" cy="301753"/>
+            <a:off x="1920240" y="5394960"/>
+            <a:ext cx="8311896" cy="0"/>
           </a:xfrm>
           <a:prstGeom prst="line">
             <a:avLst/>
@@ -13189,9 +13229,9 @@
           <p:nvPr/>
         </p:nvCxnSpPr>
         <p:spPr>
-          <a:xfrm flipH="1">
-            <a:off x="2926080" y="4279392"/>
-            <a:ext cx="7818120" cy="292608"/>
+          <a:xfrm>
+            <a:off x="6080760" y="5394960"/>
+            <a:ext cx="0" cy="27432"/>
           </a:xfrm>
           <a:prstGeom prst="line">
             <a:avLst/>
@@ -13218,48 +13258,6 @@
           </a:fontRef>
         </p:style>
       </p:cxnSp>
-      <p:sp>
-        <p:nvSpPr>
-          <p:cNvPr id="27" name="TextBox 26"/>
-          <p:cNvSpPr txBox="1"/>
-          <p:nvPr/>
-        </p:nvSpPr>
-        <p:spPr>
-          <a:xfrm>
-            <a:off x="914400" y="5257800"/>
-            <a:ext cx="10332720" cy="914400"/>
-          </a:xfrm>
-          <a:prstGeom prst="rect">
-            <a:avLst/>
-          </a:prstGeom>
-          <a:noFill/>
-        </p:spPr>
-        <p:txBody>
-          <a:bodyPr wrap="square">
-            <a:spAutoFit/>
-          </a:bodyPr>
-          <a:lstStyle/>
-          <a:p>
-            <a:pPr algn="l">
-              <a:spcBef>
-                <a:spcPts val="0"/>
-              </a:spcBef>
-              <a:spcAft>
-                <a:spcPts val="800"/>
-              </a:spcAft>
-            </a:pPr>
-            <a:r>
-              <a:rPr sz="1300" b="0" i="0">
-                <a:solidFill>
-                  <a:srgbClr val="1F2937"/>
-                </a:solidFill>
-                <a:latin typeface="Calibri"/>
-              </a:rPr>
-              <a:t>▪  Calibrate Pixels To Inches Under Fixed Geometry; Total Points Across The Roll Set The Final Roll Grade.</a:t>
-            </a:r>
-          </a:p>
-        </p:txBody>
-      </p:sp>
     </p:spTree>
   </p:cSld>
   <p:clrMapOvr>
@@ -13486,7 +13484,7 @@
         <p:spPr>
           <a:xfrm>
             <a:off x="548640" y="1417320"/>
-            <a:ext cx="2834640" cy="1417320"/>
+            <a:ext cx="2834640" cy="1554480"/>
           </a:xfrm>
           <a:prstGeom prst="roundRect">
             <a:avLst>
@@ -13628,7 +13626,7 @@
         <p:spPr>
           <a:xfrm>
             <a:off x="1417319" y="1673352"/>
-            <a:ext cx="1783080" cy="1005840"/>
+            <a:ext cx="1783080" cy="1143000"/>
           </a:xfrm>
           <a:prstGeom prst="rect">
             <a:avLst/>
@@ -13637,7 +13635,7 @@
         </p:spPr>
         <p:txBody>
           <a:bodyPr wrap="square">
-            <a:spAutoFit/>
+            <a:normAutofit/>
           </a:bodyPr>
           <a:lstStyle/>
           <a:p>
@@ -13647,7 +13645,7 @@
               </a:spcAft>
             </a:pPr>
             <a:r>
-              <a:rPr sz="1600" b="1" i="0">
+              <a:rPr sz="1400" b="1" i="0">
                 <a:solidFill>
                   <a:srgbClr val="144E4C"/>
                 </a:solidFill>
@@ -13666,7 +13664,7 @@
               </a:spcAft>
             </a:pPr>
             <a:r>
-              <a:rPr sz="1350" b="0" i="0">
+              <a:rPr sz="1150" b="0" i="0">
                 <a:solidFill>
                   <a:srgbClr val="5B6570"/>
                 </a:solidFill>
@@ -13685,7 +13683,7 @@
               </a:spcAft>
             </a:pPr>
             <a:r>
-              <a:rPr sz="1350" b="0" i="0">
+              <a:rPr sz="1150" b="0" i="0">
                 <a:solidFill>
                   <a:srgbClr val="5B6570"/>
                 </a:solidFill>
@@ -13705,7 +13703,7 @@
         <p:spPr>
           <a:xfrm>
             <a:off x="3657600" y="1417320"/>
-            <a:ext cx="2834640" cy="1417320"/>
+            <a:ext cx="2834640" cy="1554480"/>
           </a:xfrm>
           <a:prstGeom prst="roundRect">
             <a:avLst>
@@ -13847,7 +13845,7 @@
         <p:spPr>
           <a:xfrm>
             <a:off x="4526280" y="1673352"/>
-            <a:ext cx="1783080" cy="1005840"/>
+            <a:ext cx="1783080" cy="1143000"/>
           </a:xfrm>
           <a:prstGeom prst="rect">
             <a:avLst/>
@@ -13856,7 +13854,7 @@
         </p:spPr>
         <p:txBody>
           <a:bodyPr wrap="square">
-            <a:spAutoFit/>
+            <a:normAutofit/>
           </a:bodyPr>
           <a:lstStyle/>
           <a:p>
@@ -13866,7 +13864,7 @@
               </a:spcAft>
             </a:pPr>
             <a:r>
-              <a:rPr sz="1600" b="1" i="0">
+              <a:rPr sz="1400" b="1" i="0">
                 <a:solidFill>
                   <a:srgbClr val="144E4C"/>
                 </a:solidFill>
@@ -13885,7 +13883,7 @@
               </a:spcAft>
             </a:pPr>
             <a:r>
-              <a:rPr sz="1350" b="0" i="0">
+              <a:rPr sz="1150" b="0" i="0">
                 <a:solidFill>
                   <a:srgbClr val="5B6570"/>
                 </a:solidFill>
@@ -13904,7 +13902,7 @@
               </a:spcAft>
             </a:pPr>
             <a:r>
-              <a:rPr sz="1350" b="0" i="0">
+              <a:rPr sz="1150" b="0" i="0">
                 <a:solidFill>
                   <a:srgbClr val="5B6570"/>
                 </a:solidFill>
@@ -13923,7 +13921,7 @@
         </p:nvSpPr>
         <p:spPr>
           <a:xfrm>
-            <a:off x="548640" y="3063240"/>
+            <a:off x="548640" y="3108960"/>
             <a:ext cx="3520440" cy="1417320"/>
           </a:xfrm>
           <a:prstGeom prst="roundRect">
@@ -13970,7 +13968,7 @@
         </p:nvSpPr>
         <p:spPr>
           <a:xfrm>
-            <a:off x="548640" y="3063240"/>
+            <a:off x="548640" y="3108960"/>
             <a:ext cx="3520440" cy="82296"/>
           </a:xfrm>
           <a:prstGeom prst="roundRect">
@@ -14013,7 +14011,7 @@
         </p:nvSpPr>
         <p:spPr>
           <a:xfrm>
-            <a:off x="804672" y="3355848"/>
+            <a:off x="804672" y="3401568"/>
             <a:ext cx="475488" cy="475488"/>
           </a:xfrm>
           <a:prstGeom prst="ellipse">
@@ -14065,7 +14063,7 @@
         </p:nvSpPr>
         <p:spPr>
           <a:xfrm>
-            <a:off x="1417319" y="3319272"/>
+            <a:off x="1417319" y="3364991"/>
             <a:ext cx="2468880" cy="1005840"/>
           </a:xfrm>
           <a:prstGeom prst="rect">
@@ -14075,7 +14073,7 @@
         </p:spPr>
         <p:txBody>
           <a:bodyPr wrap="square">
-            <a:spAutoFit/>
+            <a:normAutofit/>
           </a:bodyPr>
           <a:lstStyle/>
           <a:p>
@@ -14085,7 +14083,7 @@
               </a:spcAft>
             </a:pPr>
             <a:r>
-              <a:rPr sz="1600" b="1" i="0">
+              <a:rPr sz="1350" b="1" i="0">
                 <a:solidFill>
                   <a:srgbClr val="144E4C"/>
                 </a:solidFill>
@@ -14104,7 +14102,7 @@
               </a:spcAft>
             </a:pPr>
             <a:r>
-              <a:rPr sz="1350" b="0" i="0">
+              <a:rPr sz="1100" b="0" i="0">
                 <a:solidFill>
                   <a:srgbClr val="5B6570"/>
                 </a:solidFill>
@@ -14123,7 +14121,7 @@
               </a:spcAft>
             </a:pPr>
             <a:r>
-              <a:rPr sz="1350" b="0" i="0">
+              <a:rPr sz="1100" b="0" i="0">
                 <a:solidFill>
                   <a:srgbClr val="5B6570"/>
                 </a:solidFill>
@@ -14142,7 +14140,7 @@
         </p:nvSpPr>
         <p:spPr>
           <a:xfrm>
-            <a:off x="4251959" y="3063240"/>
+            <a:off x="4251959" y="3108960"/>
             <a:ext cx="3520440" cy="1417320"/>
           </a:xfrm>
           <a:prstGeom prst="roundRect">
@@ -14189,7 +14187,7 @@
         </p:nvSpPr>
         <p:spPr>
           <a:xfrm>
-            <a:off x="4251959" y="3063240"/>
+            <a:off x="4251959" y="3108960"/>
             <a:ext cx="3520440" cy="82296"/>
           </a:xfrm>
           <a:prstGeom prst="roundRect">
@@ -14232,7 +14230,7 @@
         </p:nvSpPr>
         <p:spPr>
           <a:xfrm>
-            <a:off x="4507992" y="3355848"/>
+            <a:off x="4507992" y="3401568"/>
             <a:ext cx="475488" cy="475488"/>
           </a:xfrm>
           <a:prstGeom prst="ellipse">
@@ -14284,7 +14282,7 @@
         </p:nvSpPr>
         <p:spPr>
           <a:xfrm>
-            <a:off x="5120640" y="3319272"/>
+            <a:off x="5120640" y="3364991"/>
             <a:ext cx="2468880" cy="1005840"/>
           </a:xfrm>
           <a:prstGeom prst="rect">
@@ -14294,7 +14292,7 @@
         </p:spPr>
         <p:txBody>
           <a:bodyPr wrap="square">
-            <a:spAutoFit/>
+            <a:normAutofit/>
           </a:bodyPr>
           <a:lstStyle/>
           <a:p>
@@ -14304,7 +14302,7 @@
               </a:spcAft>
             </a:pPr>
             <a:r>
-              <a:rPr sz="1600" b="1" i="0">
+              <a:rPr sz="1350" b="1" i="0">
                 <a:solidFill>
                   <a:srgbClr val="144E4C"/>
                 </a:solidFill>
@@ -14323,7 +14321,7 @@
               </a:spcAft>
             </a:pPr>
             <a:r>
-              <a:rPr sz="1350" b="0" i="0">
+              <a:rPr sz="1100" b="0" i="0">
                 <a:solidFill>
                   <a:srgbClr val="5B6570"/>
                 </a:solidFill>
@@ -14342,7 +14340,7 @@
               </a:spcAft>
             </a:pPr>
             <a:r>
-              <a:rPr sz="1350" b="0" i="0">
+              <a:rPr sz="1100" b="0" i="0">
                 <a:solidFill>
                   <a:srgbClr val="5B6570"/>
                 </a:solidFill>
@@ -14361,7 +14359,7 @@
         </p:nvSpPr>
         <p:spPr>
           <a:xfrm>
-            <a:off x="7955279" y="3063240"/>
+            <a:off x="7955279" y="3108960"/>
             <a:ext cx="3520440" cy="1417320"/>
           </a:xfrm>
           <a:prstGeom prst="roundRect">
@@ -14408,7 +14406,7 @@
         </p:nvSpPr>
         <p:spPr>
           <a:xfrm>
-            <a:off x="7955279" y="3063240"/>
+            <a:off x="7955279" y="3108960"/>
             <a:ext cx="3520440" cy="82296"/>
           </a:xfrm>
           <a:prstGeom prst="roundRect">
@@ -14451,7 +14449,7 @@
         </p:nvSpPr>
         <p:spPr>
           <a:xfrm>
-            <a:off x="8211311" y="3355848"/>
+            <a:off x="8211311" y="3401568"/>
             <a:ext cx="475488" cy="475488"/>
           </a:xfrm>
           <a:prstGeom prst="ellipse">
@@ -14503,7 +14501,7 @@
         </p:nvSpPr>
         <p:spPr>
           <a:xfrm>
-            <a:off x="8823959" y="3319272"/>
+            <a:off x="8823959" y="3364991"/>
             <a:ext cx="2468880" cy="1005840"/>
           </a:xfrm>
           <a:prstGeom prst="rect">
@@ -14513,7 +14511,7 @@
         </p:spPr>
         <p:txBody>
           <a:bodyPr wrap="square">
-            <a:spAutoFit/>
+            <a:normAutofit/>
           </a:bodyPr>
           <a:lstStyle/>
           <a:p>
@@ -14523,7 +14521,7 @@
               </a:spcAft>
             </a:pPr>
             <a:r>
-              <a:rPr sz="1600" b="1" i="0">
+              <a:rPr sz="1350" b="1" i="0">
                 <a:solidFill>
                   <a:srgbClr val="144E4C"/>
                 </a:solidFill>
@@ -14542,7 +14540,7 @@
               </a:spcAft>
             </a:pPr>
             <a:r>
-              <a:rPr sz="1350" b="0" i="0">
+              <a:rPr sz="1100" b="0" i="0">
                 <a:solidFill>
                   <a:srgbClr val="5B6570"/>
                 </a:solidFill>
@@ -14561,7 +14559,7 @@
               </a:spcAft>
             </a:pPr>
             <a:r>
-              <a:rPr sz="1350" b="0" i="0">
+              <a:rPr sz="1100" b="0" i="0">
                 <a:solidFill>
                   <a:srgbClr val="5B6570"/>
                 </a:solidFill>
@@ -14580,7 +14578,7 @@
         </p:nvSpPr>
         <p:spPr>
           <a:xfrm>
-            <a:off x="548640" y="4617720"/>
+            <a:off x="548640" y="4590288"/>
             <a:ext cx="3520440" cy="1417320"/>
           </a:xfrm>
           <a:prstGeom prst="roundRect">
@@ -14627,7 +14625,7 @@
         </p:nvSpPr>
         <p:spPr>
           <a:xfrm>
-            <a:off x="548640" y="4617720"/>
+            <a:off x="548640" y="4590288"/>
             <a:ext cx="3520440" cy="82296"/>
           </a:xfrm>
           <a:prstGeom prst="roundRect">
@@ -14670,7 +14668,7 @@
         </p:nvSpPr>
         <p:spPr>
           <a:xfrm>
-            <a:off x="804672" y="4910328"/>
+            <a:off x="804672" y="4882896"/>
             <a:ext cx="475488" cy="475488"/>
           </a:xfrm>
           <a:prstGeom prst="ellipse">
@@ -14722,7 +14720,7 @@
         </p:nvSpPr>
         <p:spPr>
           <a:xfrm>
-            <a:off x="1417319" y="4873752"/>
+            <a:off x="1417319" y="4846320"/>
             <a:ext cx="2468880" cy="1005840"/>
           </a:xfrm>
           <a:prstGeom prst="rect">
@@ -14732,7 +14730,7 @@
         </p:spPr>
         <p:txBody>
           <a:bodyPr wrap="square">
-            <a:spAutoFit/>
+            <a:normAutofit/>
           </a:bodyPr>
           <a:lstStyle/>
           <a:p>
@@ -14742,7 +14740,7 @@
               </a:spcAft>
             </a:pPr>
             <a:r>
-              <a:rPr sz="1600" b="1" i="0">
+              <a:rPr sz="1350" b="1" i="0">
                 <a:solidFill>
                   <a:srgbClr val="144E4C"/>
                 </a:solidFill>
@@ -14761,7 +14759,7 @@
               </a:spcAft>
             </a:pPr>
             <a:r>
-              <a:rPr sz="1350" b="0" i="0">
+              <a:rPr sz="1100" b="0" i="0">
                 <a:solidFill>
                   <a:srgbClr val="5B6570"/>
                 </a:solidFill>
@@ -14780,7 +14778,7 @@
               </a:spcAft>
             </a:pPr>
             <a:r>
-              <a:rPr sz="1350" b="0" i="0">
+              <a:rPr sz="1100" b="0" i="0">
                 <a:solidFill>
                   <a:srgbClr val="5B6570"/>
                 </a:solidFill>
@@ -14799,7 +14797,7 @@
         </p:nvSpPr>
         <p:spPr>
           <a:xfrm>
-            <a:off x="4251959" y="4617720"/>
+            <a:off x="4251959" y="4590288"/>
             <a:ext cx="3520440" cy="1417320"/>
           </a:xfrm>
           <a:prstGeom prst="roundRect">
@@ -14846,7 +14844,7 @@
         </p:nvSpPr>
         <p:spPr>
           <a:xfrm>
-            <a:off x="4251959" y="4617720"/>
+            <a:off x="4251959" y="4590288"/>
             <a:ext cx="3520440" cy="82296"/>
           </a:xfrm>
           <a:prstGeom prst="roundRect">
@@ -14889,7 +14887,7 @@
         </p:nvSpPr>
         <p:spPr>
           <a:xfrm>
-            <a:off x="4507992" y="4910328"/>
+            <a:off x="4507992" y="4882896"/>
             <a:ext cx="475488" cy="475488"/>
           </a:xfrm>
           <a:prstGeom prst="ellipse">
@@ -14941,7 +14939,7 @@
         </p:nvSpPr>
         <p:spPr>
           <a:xfrm>
-            <a:off x="5120640" y="4873752"/>
+            <a:off x="5120640" y="4846320"/>
             <a:ext cx="2468880" cy="1005840"/>
           </a:xfrm>
           <a:prstGeom prst="rect">
@@ -14951,7 +14949,7 @@
         </p:spPr>
         <p:txBody>
           <a:bodyPr wrap="square">
-            <a:spAutoFit/>
+            <a:normAutofit/>
           </a:bodyPr>
           <a:lstStyle/>
           <a:p>
@@ -14961,7 +14959,7 @@
               </a:spcAft>
             </a:pPr>
             <a:r>
-              <a:rPr sz="1600" b="1" i="0">
+              <a:rPr sz="1350" b="1" i="0">
                 <a:solidFill>
                   <a:srgbClr val="144E4C"/>
                 </a:solidFill>
@@ -14980,7 +14978,7 @@
               </a:spcAft>
             </a:pPr>
             <a:r>
-              <a:rPr sz="1350" b="0" i="0">
+              <a:rPr sz="1100" b="0" i="0">
                 <a:solidFill>
                   <a:srgbClr val="5B6570"/>
                 </a:solidFill>
@@ -14999,7 +14997,7 @@
               </a:spcAft>
             </a:pPr>
             <a:r>
-              <a:rPr sz="1350" b="0" i="0">
+              <a:rPr sz="1100" b="0" i="0">
                 <a:solidFill>
                   <a:srgbClr val="5B6570"/>
                 </a:solidFill>
@@ -15018,7 +15016,7 @@
         </p:nvSpPr>
         <p:spPr>
           <a:xfrm>
-            <a:off x="7955279" y="4617720"/>
+            <a:off x="7955279" y="4590288"/>
             <a:ext cx="3520440" cy="1417320"/>
           </a:xfrm>
           <a:prstGeom prst="roundRect">
@@ -15065,7 +15063,7 @@
         </p:nvSpPr>
         <p:spPr>
           <a:xfrm>
-            <a:off x="7955279" y="4617720"/>
+            <a:off x="7955279" y="4590288"/>
             <a:ext cx="3520440" cy="82296"/>
           </a:xfrm>
           <a:prstGeom prst="roundRect">
@@ -15108,7 +15106,7 @@
         </p:nvSpPr>
         <p:spPr>
           <a:xfrm>
-            <a:off x="8211311" y="4910328"/>
+            <a:off x="8211311" y="4882896"/>
             <a:ext cx="475488" cy="475488"/>
           </a:xfrm>
           <a:prstGeom prst="ellipse">
@@ -15160,7 +15158,7 @@
         </p:nvSpPr>
         <p:spPr>
           <a:xfrm>
-            <a:off x="8823959" y="4873752"/>
+            <a:off x="8823959" y="4846320"/>
             <a:ext cx="2468880" cy="1005840"/>
           </a:xfrm>
           <a:prstGeom prst="rect">
@@ -15170,7 +15168,7 @@
         </p:spPr>
         <p:txBody>
           <a:bodyPr wrap="square">
-            <a:spAutoFit/>
+            <a:normAutofit/>
           </a:bodyPr>
           <a:lstStyle/>
           <a:p>
@@ -15180,7 +15178,7 @@
               </a:spcAft>
             </a:pPr>
             <a:r>
-              <a:rPr sz="1600" b="1" i="0">
+              <a:rPr sz="1350" b="1" i="0">
                 <a:solidFill>
                   <a:srgbClr val="144E4C"/>
                 </a:solidFill>
@@ -15199,7 +15197,7 @@
               </a:spcAft>
             </a:pPr>
             <a:r>
-              <a:rPr sz="1350" b="0" i="0">
+              <a:rPr sz="1100" b="0" i="0">
                 <a:solidFill>
                   <a:srgbClr val="5B6570"/>
                 </a:solidFill>
@@ -15218,7 +15216,7 @@
               </a:spcAft>
             </a:pPr>
             <a:r>
-              <a:rPr sz="1350" b="0" i="0">
+              <a:rPr sz="1100" b="0" i="0">
                 <a:solidFill>
                   <a:srgbClr val="5B6570"/>
                 </a:solidFill>
@@ -15455,7 +15453,7 @@
         <p:spPr>
           <a:xfrm>
             <a:off x="548640" y="1554480"/>
-            <a:ext cx="3520440" cy="4023360"/>
+            <a:ext cx="3520440" cy="2651760"/>
           </a:xfrm>
           <a:prstGeom prst="roundRect">
             <a:avLst>
@@ -15597,7 +15595,7 @@
         <p:spPr>
           <a:xfrm>
             <a:off x="1417319" y="1810512"/>
-            <a:ext cx="2468880" cy="3611880"/>
+            <a:ext cx="2468880" cy="2240279"/>
           </a:xfrm>
           <a:prstGeom prst="rect">
             <a:avLst/>
@@ -15606,7 +15604,7 @@
         </p:spPr>
         <p:txBody>
           <a:bodyPr wrap="square">
-            <a:spAutoFit/>
+            <a:normAutofit/>
           </a:bodyPr>
           <a:lstStyle/>
           <a:p>
@@ -15655,7 +15653,7 @@
         <p:spPr>
           <a:xfrm>
             <a:off x="4251959" y="1554480"/>
-            <a:ext cx="3520440" cy="4023360"/>
+            <a:ext cx="3520440" cy="2651760"/>
           </a:xfrm>
           <a:prstGeom prst="roundRect">
             <a:avLst>
@@ -15797,7 +15795,7 @@
         <p:spPr>
           <a:xfrm>
             <a:off x="5120640" y="1810512"/>
-            <a:ext cx="2468880" cy="3611880"/>
+            <a:ext cx="2468880" cy="2240279"/>
           </a:xfrm>
           <a:prstGeom prst="rect">
             <a:avLst/>
@@ -15806,7 +15804,7 @@
         </p:spPr>
         <p:txBody>
           <a:bodyPr wrap="square">
-            <a:spAutoFit/>
+            <a:normAutofit/>
           </a:bodyPr>
           <a:lstStyle/>
           <a:p>
@@ -15855,7 +15853,7 @@
         <p:spPr>
           <a:xfrm>
             <a:off x="7955279" y="1554480"/>
-            <a:ext cx="3520440" cy="4023360"/>
+            <a:ext cx="3520440" cy="2651760"/>
           </a:xfrm>
           <a:prstGeom prst="roundRect">
             <a:avLst>
@@ -15997,7 +15995,7 @@
         <p:spPr>
           <a:xfrm>
             <a:off x="8823959" y="1810512"/>
-            <a:ext cx="2468880" cy="3611880"/>
+            <a:ext cx="2468880" cy="2240279"/>
           </a:xfrm>
           <a:prstGeom prst="rect">
             <a:avLst/>
@@ -16006,7 +16004,7 @@
         </p:spPr>
         <p:txBody>
           <a:bodyPr wrap="square">
-            <a:spAutoFit/>
+            <a:normAutofit/>
           </a:bodyPr>
           <a:lstStyle/>
           <a:p>
@@ -20403,7 +20401,7 @@
         <p:spPr>
           <a:xfrm>
             <a:off x="548640" y="1463040"/>
-            <a:ext cx="5394960" cy="3291840"/>
+            <a:ext cx="5394960" cy="2926080"/>
           </a:xfrm>
           <a:prstGeom prst="roundRect">
             <a:avLst>
@@ -20545,7 +20543,7 @@
         <p:spPr>
           <a:xfrm>
             <a:off x="1417319" y="1719072"/>
-            <a:ext cx="4343400" cy="2880360"/>
+            <a:ext cx="4343400" cy="2514600"/>
           </a:xfrm>
           <a:prstGeom prst="rect">
             <a:avLst/>
@@ -20554,7 +20552,7 @@
         </p:spPr>
         <p:txBody>
           <a:bodyPr wrap="square">
-            <a:spAutoFit/>
+            <a:normAutofit/>
           </a:bodyPr>
           <a:lstStyle/>
           <a:p>
@@ -20641,7 +20639,7 @@
         <p:spPr>
           <a:xfrm>
             <a:off x="6245352" y="1463040"/>
-            <a:ext cx="5394960" cy="3291840"/>
+            <a:ext cx="5394960" cy="2926080"/>
           </a:xfrm>
           <a:prstGeom prst="roundRect">
             <a:avLst>
@@ -20783,7 +20781,7 @@
         <p:spPr>
           <a:xfrm>
             <a:off x="7114032" y="1719072"/>
-            <a:ext cx="4343400" cy="2880360"/>
+            <a:ext cx="4343400" cy="2514600"/>
           </a:xfrm>
           <a:prstGeom prst="rect">
             <a:avLst/>
@@ -20792,7 +20790,7 @@
         </p:spPr>
         <p:txBody>
           <a:bodyPr wrap="square">
-            <a:spAutoFit/>
+            <a:normAutofit/>
           </a:bodyPr>
           <a:lstStyle/>
           <a:p>
@@ -22214,14 +22212,16 @@
         </p:nvSpPr>
         <p:spPr>
           <a:xfrm>
-            <a:off x="6309360" y="4709160"/>
-            <a:ext cx="5303520" cy="1143000"/>
+            <a:off x="548640" y="5074920"/>
+            <a:ext cx="11064240" cy="777240"/>
           </a:xfrm>
           <a:prstGeom prst="roundRect">
-            <a:avLst/>
+            <a:avLst>
+              <a:gd name="adj" fmla="val 12000"/>
+            </a:avLst>
           </a:prstGeom>
           <a:solidFill>
-            <a:srgbClr val="2B7BC4"/>
+            <a:srgbClr val="144E4C"/>
           </a:solidFill>
           <a:ln>
             <a:noFill/>
@@ -22247,7 +22247,7 @@
           <a:p>
             <a:pPr algn="ctr"/>
             <a:r>
-              <a:rPr sz="1700" b="1" i="0">
+              <a:rPr sz="1600" b="1" i="0">
                 <a:solidFill>
                   <a:srgbClr val="FFFFFF"/>
                 </a:solidFill>
@@ -23638,7 +23638,7 @@
         </p:spPr>
         <p:txBody>
           <a:bodyPr wrap="square">
-            <a:spAutoFit/>
+            <a:normAutofit/>
           </a:bodyPr>
           <a:lstStyle/>
           <a:p>
@@ -23838,7 +23838,7 @@
         </p:spPr>
         <p:txBody>
           <a:bodyPr wrap="square">
-            <a:spAutoFit/>
+            <a:normAutofit/>
           </a:bodyPr>
           <a:lstStyle/>
           <a:p>
@@ -24038,7 +24038,7 @@
         </p:spPr>
         <p:txBody>
           <a:bodyPr wrap="square">
-            <a:spAutoFit/>
+            <a:normAutofit/>
           </a:bodyPr>
           <a:lstStyle/>
           <a:p>
@@ -24238,7 +24238,7 @@
         </p:spPr>
         <p:txBody>
           <a:bodyPr wrap="square">
-            <a:spAutoFit/>
+            <a:normAutofit/>
           </a:bodyPr>
           <a:lstStyle/>
           <a:p>
@@ -24438,7 +24438,7 @@
         </p:spPr>
         <p:txBody>
           <a:bodyPr wrap="square">
-            <a:spAutoFit/>
+            <a:normAutofit/>
           </a:bodyPr>
           <a:lstStyle/>
           <a:p>
@@ -24638,7 +24638,7 @@
         </p:spPr>
         <p:txBody>
           <a:bodyPr wrap="square">
-            <a:spAutoFit/>
+            <a:normAutofit/>
           </a:bodyPr>
           <a:lstStyle/>
           <a:p>

</xml_diff>

<commit_message>
docs(slides): gold accent theme, slide-18 fan-in arrows, big-type req graphics
</commit_message>
<xml_diff>
--- a/slides/FYDP-I_Defect-to-Delivery.pptx
+++ b/slides/FYDP-I_Defect-to-Delivery.pptx
@@ -3207,7 +3207,7 @@
             <a:avLst/>
           </a:prstGeom>
           <a:solidFill>
-            <a:srgbClr val="1B7A6E"/>
+            <a:srgbClr val="D99A06"/>
           </a:solidFill>
           <a:ln>
             <a:noFill/>
@@ -3523,7 +3523,7 @@
             <a:avLst/>
           </a:prstGeom>
           <a:solidFill>
-            <a:srgbClr val="1B7A6E"/>
+            <a:srgbClr val="D99A06"/>
           </a:solidFill>
           <a:ln>
             <a:noFill/>
@@ -3601,7 +3601,7 @@
             <a:avLst/>
           </a:prstGeom>
           <a:solidFill>
-            <a:srgbClr val="1B7A6E"/>
+            <a:srgbClr val="D99A06"/>
           </a:solidFill>
           <a:ln>
             <a:noFill/>
@@ -5056,7 +5056,7 @@
             <a:avLst/>
           </a:prstGeom>
           <a:solidFill>
-            <a:srgbClr val="1B7A6E"/>
+            <a:srgbClr val="D99A06"/>
           </a:solidFill>
           <a:ln>
             <a:noFill/>
@@ -5134,7 +5134,7 @@
             <a:avLst/>
           </a:prstGeom>
           <a:solidFill>
-            <a:srgbClr val="1B7A6E"/>
+            <a:srgbClr val="D99A06"/>
           </a:solidFill>
           <a:ln>
             <a:noFill/>
@@ -5224,7 +5224,7 @@
             <a:avLst/>
           </a:prstGeom>
           <a:solidFill>
-            <a:srgbClr val="1B7A6E"/>
+            <a:srgbClr val="D99A06"/>
           </a:solidFill>
           <a:ln>
             <a:noFill/>
@@ -5267,7 +5267,7 @@
             <a:avLst/>
           </a:prstGeom>
           <a:solidFill>
-            <a:srgbClr val="1B7A6E"/>
+            <a:srgbClr val="D99A06"/>
           </a:solidFill>
           <a:ln>
             <a:noFill/>
@@ -5424,7 +5424,7 @@
             <a:avLst/>
           </a:prstGeom>
           <a:solidFill>
-            <a:srgbClr val="1B7A6E"/>
+            <a:srgbClr val="D99A06"/>
           </a:solidFill>
           <a:ln>
             <a:noFill/>
@@ -5467,7 +5467,7 @@
             <a:avLst/>
           </a:prstGeom>
           <a:solidFill>
-            <a:srgbClr val="1B7A6E"/>
+            <a:srgbClr val="D99A06"/>
           </a:solidFill>
           <a:ln>
             <a:noFill/>
@@ -5624,7 +5624,7 @@
             <a:avLst/>
           </a:prstGeom>
           <a:solidFill>
-            <a:srgbClr val="1B7A6E"/>
+            <a:srgbClr val="D99A06"/>
           </a:solidFill>
           <a:ln>
             <a:noFill/>
@@ -5667,7 +5667,7 @@
             <a:avLst/>
           </a:prstGeom>
           <a:solidFill>
-            <a:srgbClr val="1B7A6E"/>
+            <a:srgbClr val="D99A06"/>
           </a:solidFill>
           <a:ln>
             <a:noFill/>
@@ -5824,7 +5824,7 @@
             <a:avLst/>
           </a:prstGeom>
           <a:solidFill>
-            <a:srgbClr val="1B7A6E"/>
+            <a:srgbClr val="D99A06"/>
           </a:solidFill>
           <a:ln>
             <a:noFill/>
@@ -5867,7 +5867,7 @@
             <a:avLst/>
           </a:prstGeom>
           <a:solidFill>
-            <a:srgbClr val="1B7A6E"/>
+            <a:srgbClr val="D99A06"/>
           </a:solidFill>
           <a:ln>
             <a:noFill/>
@@ -6108,7 +6108,7 @@
             <a:avLst/>
           </a:prstGeom>
           <a:solidFill>
-            <a:srgbClr val="1B7A6E"/>
+            <a:srgbClr val="D99A06"/>
           </a:solidFill>
           <a:ln>
             <a:noFill/>
@@ -6186,7 +6186,7 @@
             <a:avLst/>
           </a:prstGeom>
           <a:solidFill>
-            <a:srgbClr val="1B7A6E"/>
+            <a:srgbClr val="D99A06"/>
           </a:solidFill>
           <a:ln>
             <a:noFill/>
@@ -6485,7 +6485,7 @@
             <a:avLst/>
           </a:prstGeom>
           <a:solidFill>
-            <a:srgbClr val="1B7A6E"/>
+            <a:srgbClr val="D99A06"/>
           </a:solidFill>
           <a:ln>
             <a:noFill/>
@@ -6563,7 +6563,7 @@
             <a:avLst/>
           </a:prstGeom>
           <a:solidFill>
-            <a:srgbClr val="1B7A6E"/>
+            <a:srgbClr val="D99A06"/>
           </a:solidFill>
           <a:ln>
             <a:noFill/>
@@ -7469,7 +7469,7 @@
             <a:avLst/>
           </a:prstGeom>
           <a:solidFill>
-            <a:srgbClr val="1B7A6E"/>
+            <a:srgbClr val="D99A06"/>
           </a:solidFill>
           <a:ln>
             <a:noFill/>
@@ -7547,7 +7547,7 @@
             <a:avLst/>
           </a:prstGeom>
           <a:solidFill>
-            <a:srgbClr val="1B7A6E"/>
+            <a:srgbClr val="D99A06"/>
           </a:solidFill>
           <a:ln>
             <a:noFill/>
@@ -7637,7 +7637,7 @@
             <a:avLst/>
           </a:prstGeom>
           <a:solidFill>
-            <a:srgbClr val="1B7A6E"/>
+            <a:srgbClr val="D99A06"/>
           </a:solidFill>
           <a:ln>
             <a:noFill/>
@@ -7680,7 +7680,7 @@
             <a:avLst/>
           </a:prstGeom>
           <a:solidFill>
-            <a:srgbClr val="1B7A6E"/>
+            <a:srgbClr val="D99A06"/>
           </a:solidFill>
           <a:ln>
             <a:noFill/>
@@ -7875,7 +7875,7 @@
             <a:avLst/>
           </a:prstGeom>
           <a:solidFill>
-            <a:srgbClr val="1B7A6E"/>
+            <a:srgbClr val="D99A06"/>
           </a:solidFill>
           <a:ln>
             <a:noFill/>
@@ -7918,7 +7918,7 @@
             <a:avLst/>
           </a:prstGeom>
           <a:solidFill>
-            <a:srgbClr val="1B7A6E"/>
+            <a:srgbClr val="D99A06"/>
           </a:solidFill>
           <a:ln>
             <a:noFill/>
@@ -8200,7 +8200,7 @@
             <a:avLst/>
           </a:prstGeom>
           <a:solidFill>
-            <a:srgbClr val="1B7A6E"/>
+            <a:srgbClr val="D99A06"/>
           </a:solidFill>
           <a:ln>
             <a:noFill/>
@@ -8278,7 +8278,7 @@
             <a:avLst/>
           </a:prstGeom>
           <a:solidFill>
-            <a:srgbClr val="1B7A6E"/>
+            <a:srgbClr val="D99A06"/>
           </a:solidFill>
           <a:ln>
             <a:noFill/>
@@ -9136,7 +9136,7 @@
             <a:avLst/>
           </a:prstGeom>
           <a:solidFill>
-            <a:srgbClr val="1B7A6E"/>
+            <a:srgbClr val="D99A06"/>
           </a:solidFill>
           <a:ln>
             <a:noFill/>
@@ -9214,7 +9214,7 @@
             <a:avLst/>
           </a:prstGeom>
           <a:solidFill>
-            <a:srgbClr val="1B7A6E"/>
+            <a:srgbClr val="D99A06"/>
           </a:solidFill>
           <a:ln>
             <a:noFill/>
@@ -10075,7 +10075,7 @@
             <a:avLst/>
           </a:prstGeom>
           <a:solidFill>
-            <a:srgbClr val="1B7A6E"/>
+            <a:srgbClr val="D99A06"/>
           </a:solidFill>
           <a:ln>
             <a:noFill/>
@@ -10153,7 +10153,7 @@
             <a:avLst/>
           </a:prstGeom>
           <a:solidFill>
-            <a:srgbClr val="1B7A6E"/>
+            <a:srgbClr val="D99A06"/>
           </a:solidFill>
           <a:ln>
             <a:noFill/>
@@ -11415,7 +11415,7 @@
             <a:avLst/>
           </a:prstGeom>
           <a:solidFill>
-            <a:srgbClr val="1B7A6E"/>
+            <a:srgbClr val="D99A06"/>
           </a:solidFill>
           <a:ln>
             <a:noFill/>
@@ -11493,7 +11493,7 @@
             <a:avLst/>
           </a:prstGeom>
           <a:solidFill>
-            <a:srgbClr val="1B7A6E"/>
+            <a:srgbClr val="D99A06"/>
           </a:solidFill>
           <a:ln>
             <a:noFill/>
@@ -11883,8 +11883,8 @@
         </p:nvCxnSpPr>
         <p:spPr>
           <a:xfrm>
-            <a:off x="2560320" y="2103120"/>
-            <a:ext cx="530352" cy="731520"/>
+            <a:off x="2578608" y="2103120"/>
+            <a:ext cx="512064" cy="594360"/>
           </a:xfrm>
           <a:prstGeom prst="line">
             <a:avLst/>
@@ -11919,8 +11919,8 @@
         </p:nvCxnSpPr>
         <p:spPr>
           <a:xfrm flipV="1">
-            <a:off x="2560320" y="2834640"/>
-            <a:ext cx="530352" cy="411480"/>
+            <a:off x="2578608" y="3063240"/>
+            <a:ext cx="512064" cy="182880"/>
           </a:xfrm>
           <a:prstGeom prst="line">
             <a:avLst/>
@@ -11955,8 +11955,8 @@
         </p:nvCxnSpPr>
         <p:spPr>
           <a:xfrm flipV="1">
-            <a:off x="2560320" y="2834640"/>
-            <a:ext cx="530352" cy="1554480"/>
+            <a:off x="2578608" y="3429000"/>
+            <a:ext cx="512064" cy="960120"/>
           </a:xfrm>
           <a:prstGeom prst="line">
             <a:avLst/>
@@ -12253,7 +12253,7 @@
             <a:avLst/>
           </a:prstGeom>
           <a:solidFill>
-            <a:srgbClr val="1B7A6E"/>
+            <a:srgbClr val="D99A06"/>
           </a:solidFill>
           <a:ln>
             <a:noFill/>
@@ -12331,7 +12331,7 @@
             <a:avLst/>
           </a:prstGeom>
           <a:solidFill>
-            <a:srgbClr val="1B7A6E"/>
+            <a:srgbClr val="D99A06"/>
           </a:solidFill>
           <a:ln>
             <a:noFill/>
@@ -13369,7 +13369,7 @@
             <a:avLst/>
           </a:prstGeom>
           <a:solidFill>
-            <a:srgbClr val="1B7A6E"/>
+            <a:srgbClr val="D99A06"/>
           </a:solidFill>
           <a:ln>
             <a:noFill/>
@@ -13447,7 +13447,7 @@
             <a:avLst/>
           </a:prstGeom>
           <a:solidFill>
-            <a:srgbClr val="1B7A6E"/>
+            <a:srgbClr val="D99A06"/>
           </a:solidFill>
           <a:ln>
             <a:noFill/>
@@ -13537,7 +13537,7 @@
             <a:avLst/>
           </a:prstGeom>
           <a:solidFill>
-            <a:srgbClr val="1B7A6E"/>
+            <a:srgbClr val="D99A06"/>
           </a:solidFill>
           <a:ln>
             <a:noFill/>
@@ -13580,7 +13580,7 @@
             <a:avLst/>
           </a:prstGeom>
           <a:solidFill>
-            <a:srgbClr val="1B7A6E"/>
+            <a:srgbClr val="D99A06"/>
           </a:solidFill>
           <a:ln>
             <a:noFill/>
@@ -13756,7 +13756,7 @@
             <a:avLst/>
           </a:prstGeom>
           <a:solidFill>
-            <a:srgbClr val="1B7A6E"/>
+            <a:srgbClr val="D99A06"/>
           </a:solidFill>
           <a:ln>
             <a:noFill/>
@@ -13799,7 +13799,7 @@
             <a:avLst/>
           </a:prstGeom>
           <a:solidFill>
-            <a:srgbClr val="1B7A6E"/>
+            <a:srgbClr val="D99A06"/>
           </a:solidFill>
           <a:ln>
             <a:noFill/>
@@ -13975,7 +13975,7 @@
             <a:avLst/>
           </a:prstGeom>
           <a:solidFill>
-            <a:srgbClr val="1B7A6E"/>
+            <a:srgbClr val="D99A06"/>
           </a:solidFill>
           <a:ln>
             <a:noFill/>
@@ -14018,7 +14018,7 @@
             <a:avLst/>
           </a:prstGeom>
           <a:solidFill>
-            <a:srgbClr val="1B7A6E"/>
+            <a:srgbClr val="D99A06"/>
           </a:solidFill>
           <a:ln>
             <a:noFill/>
@@ -14194,7 +14194,7 @@
             <a:avLst/>
           </a:prstGeom>
           <a:solidFill>
-            <a:srgbClr val="1B7A6E"/>
+            <a:srgbClr val="D99A06"/>
           </a:solidFill>
           <a:ln>
             <a:noFill/>
@@ -14237,7 +14237,7 @@
             <a:avLst/>
           </a:prstGeom>
           <a:solidFill>
-            <a:srgbClr val="1B7A6E"/>
+            <a:srgbClr val="D99A06"/>
           </a:solidFill>
           <a:ln>
             <a:noFill/>
@@ -14413,7 +14413,7 @@
             <a:avLst/>
           </a:prstGeom>
           <a:solidFill>
-            <a:srgbClr val="1B7A6E"/>
+            <a:srgbClr val="D99A06"/>
           </a:solidFill>
           <a:ln>
             <a:noFill/>
@@ -14456,7 +14456,7 @@
             <a:avLst/>
           </a:prstGeom>
           <a:solidFill>
-            <a:srgbClr val="1B7A6E"/>
+            <a:srgbClr val="D99A06"/>
           </a:solidFill>
           <a:ln>
             <a:noFill/>
@@ -14632,7 +14632,7 @@
             <a:avLst/>
           </a:prstGeom>
           <a:solidFill>
-            <a:srgbClr val="1B7A6E"/>
+            <a:srgbClr val="D99A06"/>
           </a:solidFill>
           <a:ln>
             <a:noFill/>
@@ -14675,7 +14675,7 @@
             <a:avLst/>
           </a:prstGeom>
           <a:solidFill>
-            <a:srgbClr val="1B7A6E"/>
+            <a:srgbClr val="D99A06"/>
           </a:solidFill>
           <a:ln>
             <a:noFill/>
@@ -14851,7 +14851,7 @@
             <a:avLst/>
           </a:prstGeom>
           <a:solidFill>
-            <a:srgbClr val="1B7A6E"/>
+            <a:srgbClr val="D99A06"/>
           </a:solidFill>
           <a:ln>
             <a:noFill/>
@@ -14894,7 +14894,7 @@
             <a:avLst/>
           </a:prstGeom>
           <a:solidFill>
-            <a:srgbClr val="1B7A6E"/>
+            <a:srgbClr val="D99A06"/>
           </a:solidFill>
           <a:ln>
             <a:noFill/>
@@ -15070,7 +15070,7 @@
             <a:avLst/>
           </a:prstGeom>
           <a:solidFill>
-            <a:srgbClr val="1B7A6E"/>
+            <a:srgbClr val="D99A06"/>
           </a:solidFill>
           <a:ln>
             <a:noFill/>
@@ -15113,7 +15113,7 @@
             <a:avLst/>
           </a:prstGeom>
           <a:solidFill>
-            <a:srgbClr val="1B7A6E"/>
+            <a:srgbClr val="D99A06"/>
           </a:solidFill>
           <a:ln>
             <a:noFill/>
@@ -15338,7 +15338,7 @@
             <a:avLst/>
           </a:prstGeom>
           <a:solidFill>
-            <a:srgbClr val="1B7A6E"/>
+            <a:srgbClr val="D99A06"/>
           </a:solidFill>
           <a:ln>
             <a:noFill/>
@@ -15416,7 +15416,7 @@
             <a:avLst/>
           </a:prstGeom>
           <a:solidFill>
-            <a:srgbClr val="1B7A6E"/>
+            <a:srgbClr val="D99A06"/>
           </a:solidFill>
           <a:ln>
             <a:noFill/>
@@ -15506,7 +15506,7 @@
             <a:avLst/>
           </a:prstGeom>
           <a:solidFill>
-            <a:srgbClr val="1B7A6E"/>
+            <a:srgbClr val="D99A06"/>
           </a:solidFill>
           <a:ln>
             <a:noFill/>
@@ -15549,7 +15549,7 @@
             <a:avLst/>
           </a:prstGeom>
           <a:solidFill>
-            <a:srgbClr val="1B7A6E"/>
+            <a:srgbClr val="D99A06"/>
           </a:solidFill>
           <a:ln>
             <a:noFill/>
@@ -15706,7 +15706,7 @@
             <a:avLst/>
           </a:prstGeom>
           <a:solidFill>
-            <a:srgbClr val="1B7A6E"/>
+            <a:srgbClr val="D99A06"/>
           </a:solidFill>
           <a:ln>
             <a:noFill/>
@@ -15749,7 +15749,7 @@
             <a:avLst/>
           </a:prstGeom>
           <a:solidFill>
-            <a:srgbClr val="1B7A6E"/>
+            <a:srgbClr val="D99A06"/>
           </a:solidFill>
           <a:ln>
             <a:noFill/>
@@ -15906,7 +15906,7 @@
             <a:avLst/>
           </a:prstGeom>
           <a:solidFill>
-            <a:srgbClr val="1B7A6E"/>
+            <a:srgbClr val="D99A06"/>
           </a:solidFill>
           <a:ln>
             <a:noFill/>
@@ -15949,7 +15949,7 @@
             <a:avLst/>
           </a:prstGeom>
           <a:solidFill>
-            <a:srgbClr val="1B7A6E"/>
+            <a:srgbClr val="D99A06"/>
           </a:solidFill>
           <a:ln>
             <a:noFill/>
@@ -16155,7 +16155,7 @@
             <a:avLst/>
           </a:prstGeom>
           <a:solidFill>
-            <a:srgbClr val="1B7A6E"/>
+            <a:srgbClr val="D99A06"/>
           </a:solidFill>
           <a:ln>
             <a:noFill/>
@@ -16233,7 +16233,7 @@
             <a:avLst/>
           </a:prstGeom>
           <a:solidFill>
-            <a:srgbClr val="1B7A6E"/>
+            <a:srgbClr val="D99A06"/>
           </a:solidFill>
           <a:ln>
             <a:noFill/>
@@ -16830,7 +16830,7 @@
             <a:avLst/>
           </a:prstGeom>
           <a:solidFill>
-            <a:srgbClr val="1B7A6E"/>
+            <a:srgbClr val="D99A06"/>
           </a:solidFill>
           <a:ln>
             <a:noFill/>
@@ -16908,7 +16908,7 @@
             <a:avLst/>
           </a:prstGeom>
           <a:solidFill>
-            <a:srgbClr val="1B7A6E"/>
+            <a:srgbClr val="D99A06"/>
           </a:solidFill>
           <a:ln>
             <a:noFill/>
@@ -18050,7 +18050,7 @@
             <a:avLst/>
           </a:prstGeom>
           <a:solidFill>
-            <a:srgbClr val="1B7A6E"/>
+            <a:srgbClr val="D99A06"/>
           </a:solidFill>
           <a:ln>
             <a:noFill/>
@@ -18128,7 +18128,7 @@
             <a:avLst/>
           </a:prstGeom>
           <a:solidFill>
-            <a:srgbClr val="1B7A6E"/>
+            <a:srgbClr val="D99A06"/>
           </a:solidFill>
           <a:ln>
             <a:noFill/>
@@ -19176,7 +19176,7 @@
             <a:avLst/>
           </a:prstGeom>
           <a:solidFill>
-            <a:srgbClr val="1B7A6E"/>
+            <a:srgbClr val="D99A06"/>
           </a:solidFill>
           <a:ln>
             <a:noFill/>
@@ -19254,7 +19254,7 @@
             <a:avLst/>
           </a:prstGeom>
           <a:solidFill>
-            <a:srgbClr val="1B7A6E"/>
+            <a:srgbClr val="D99A06"/>
           </a:solidFill>
           <a:ln>
             <a:noFill/>
@@ -19707,7 +19707,7 @@
             <a:avLst/>
           </a:prstGeom>
           <a:solidFill>
-            <a:srgbClr val="1B7A6E"/>
+            <a:srgbClr val="D99A06"/>
           </a:solidFill>
           <a:ln>
             <a:noFill/>
@@ -19785,7 +19785,7 @@
             <a:avLst/>
           </a:prstGeom>
           <a:solidFill>
-            <a:srgbClr val="1B7A6E"/>
+            <a:srgbClr val="D99A06"/>
           </a:solidFill>
           <a:ln>
             <a:noFill/>
@@ -20286,7 +20286,7 @@
             <a:avLst/>
           </a:prstGeom>
           <a:solidFill>
-            <a:srgbClr val="1B7A6E"/>
+            <a:srgbClr val="D99A06"/>
           </a:solidFill>
           <a:ln>
             <a:noFill/>
@@ -20364,7 +20364,7 @@
             <a:avLst/>
           </a:prstGeom>
           <a:solidFill>
-            <a:srgbClr val="1B7A6E"/>
+            <a:srgbClr val="D99A06"/>
           </a:solidFill>
           <a:ln>
             <a:noFill/>
@@ -20454,7 +20454,7 @@
             <a:avLst/>
           </a:prstGeom>
           <a:solidFill>
-            <a:srgbClr val="1B7A6E"/>
+            <a:srgbClr val="D99A06"/>
           </a:solidFill>
           <a:ln>
             <a:noFill/>
@@ -20497,7 +20497,7 @@
             <a:avLst/>
           </a:prstGeom>
           <a:solidFill>
-            <a:srgbClr val="1B7A6E"/>
+            <a:srgbClr val="D99A06"/>
           </a:solidFill>
           <a:ln>
             <a:noFill/>
@@ -20692,7 +20692,7 @@
             <a:avLst/>
           </a:prstGeom>
           <a:solidFill>
-            <a:srgbClr val="1B7A6E"/>
+            <a:srgbClr val="D99A06"/>
           </a:solidFill>
           <a:ln>
             <a:noFill/>
@@ -20735,7 +20735,7 @@
             <a:avLst/>
           </a:prstGeom>
           <a:solidFill>
-            <a:srgbClr val="1B7A6E"/>
+            <a:srgbClr val="D99A06"/>
           </a:solidFill>
           <a:ln>
             <a:noFill/>
@@ -21052,7 +21052,7 @@
             <a:avLst/>
           </a:prstGeom>
           <a:solidFill>
-            <a:srgbClr val="1B7A6E"/>
+            <a:srgbClr val="D99A06"/>
           </a:solidFill>
           <a:ln>
             <a:noFill/>
@@ -21296,7 +21296,7 @@
             <a:avLst/>
           </a:prstGeom>
           <a:solidFill>
-            <a:srgbClr val="1B7A6E"/>
+            <a:srgbClr val="D99A06"/>
           </a:solidFill>
           <a:ln>
             <a:noFill/>
@@ -21374,7 +21374,7 @@
             <a:avLst/>
           </a:prstGeom>
           <a:solidFill>
-            <a:srgbClr val="1B7A6E"/>
+            <a:srgbClr val="D99A06"/>
           </a:solidFill>
           <a:ln>
             <a:noFill/>
@@ -21447,11 +21447,20 @@
             <a:r>
               <a:rPr sz="1600" b="1" i="0">
                 <a:solidFill>
+                  <a:srgbClr val="8A6204"/>
+                </a:solidFill>
+                <a:latin typeface="Calibri"/>
+              </a:rPr>
+              <a:t>1.  </a:t>
+            </a:r>
+            <a:r>
+              <a:rPr sz="1600" b="1">
+                <a:solidFill>
                   <a:srgbClr val="144E4C"/>
                 </a:solidFill>
                 <a:latin typeface="Calibri"/>
               </a:rPr>
-              <a:t>1.  Problem &amp; Motivation</a:t>
+              <a:t>Problem &amp; Motivation</a:t>
             </a:r>
           </a:p>
         </p:txBody>
@@ -21501,11 +21510,20 @@
             <a:r>
               <a:rPr sz="1600" b="1" i="0">
                 <a:solidFill>
+                  <a:srgbClr val="8A6204"/>
+                </a:solidFill>
+                <a:latin typeface="Calibri"/>
+              </a:rPr>
+              <a:t>2.  </a:t>
+            </a:r>
+            <a:r>
+              <a:rPr sz="1600" b="1">
+                <a:solidFill>
                   <a:srgbClr val="144E4C"/>
                 </a:solidFill>
                 <a:latin typeface="Calibri"/>
               </a:rPr>
-              <a:t>2.  Objectives &amp; Methodology</a:t>
+              <a:t>Objectives &amp; Methodology</a:t>
             </a:r>
           </a:p>
         </p:txBody>
@@ -21555,11 +21573,20 @@
             <a:r>
               <a:rPr sz="1600" b="1" i="0">
                 <a:solidFill>
+                  <a:srgbClr val="8A6204"/>
+                </a:solidFill>
+                <a:latin typeface="Calibri"/>
+              </a:rPr>
+              <a:t>3.  </a:t>
+            </a:r>
+            <a:r>
+              <a:rPr sz="1600" b="1">
+                <a:solidFill>
                   <a:srgbClr val="144E4C"/>
                 </a:solidFill>
                 <a:latin typeface="Calibri"/>
               </a:rPr>
-              <a:t>3.  Literature Review &amp; Gap Analysis</a:t>
+              <a:t>Literature Review &amp; Gap Analysis</a:t>
             </a:r>
           </a:p>
         </p:txBody>
@@ -21609,11 +21636,20 @@
             <a:r>
               <a:rPr sz="1600" b="1" i="0">
                 <a:solidFill>
+                  <a:srgbClr val="8A6204"/>
+                </a:solidFill>
+                <a:latin typeface="Calibri"/>
+              </a:rPr>
+              <a:t>4.  </a:t>
+            </a:r>
+            <a:r>
+              <a:rPr sz="1600" b="1">
+                <a:solidFill>
                   <a:srgbClr val="144E4C"/>
                 </a:solidFill>
                 <a:latin typeface="Calibri"/>
               </a:rPr>
-              <a:t>4.  Requirement Analysis</a:t>
+              <a:t>Requirement Analysis</a:t>
             </a:r>
           </a:p>
         </p:txBody>
@@ -21663,11 +21699,20 @@
             <a:r>
               <a:rPr sz="1600" b="1" i="0">
                 <a:solidFill>
+                  <a:srgbClr val="8A6204"/>
+                </a:solidFill>
+                <a:latin typeface="Calibri"/>
+              </a:rPr>
+              <a:t>5.  </a:t>
+            </a:r>
+            <a:r>
+              <a:rPr sz="1600" b="1">
+                <a:solidFill>
                   <a:srgbClr val="144E4C"/>
                 </a:solidFill>
                 <a:latin typeface="Calibri"/>
               </a:rPr>
-              <a:t>5.  Dataset Audit</a:t>
+              <a:t>Dataset Audit</a:t>
             </a:r>
           </a:p>
         </p:txBody>
@@ -21717,11 +21762,20 @@
             <a:r>
               <a:rPr sz="1600" b="1" i="0">
                 <a:solidFill>
+                  <a:srgbClr val="8A6204"/>
+                </a:solidFill>
+                <a:latin typeface="Calibri"/>
+              </a:rPr>
+              <a:t>6.  </a:t>
+            </a:r>
+            <a:r>
+              <a:rPr sz="1600" b="1">
+                <a:solidFill>
                   <a:srgbClr val="144E4C"/>
                 </a:solidFill>
                 <a:latin typeface="Calibri"/>
               </a:rPr>
-              <a:t>6.  System Design &amp; Diagrams</a:t>
+              <a:t>System Design &amp; Diagrams</a:t>
             </a:r>
           </a:p>
         </p:txBody>
@@ -21771,11 +21825,20 @@
             <a:r>
               <a:rPr sz="1600" b="1" i="0">
                 <a:solidFill>
+                  <a:srgbClr val="8A6204"/>
+                </a:solidFill>
+                <a:latin typeface="Calibri"/>
+              </a:rPr>
+              <a:t>7.  </a:t>
+            </a:r>
+            <a:r>
+              <a:rPr sz="1600" b="1">
+                <a:solidFill>
                   <a:srgbClr val="144E4C"/>
                 </a:solidFill>
                 <a:latin typeface="Calibri"/>
               </a:rPr>
-              <a:t>7.  Standards &amp; Constraints</a:t>
+              <a:t>Standards &amp; Constraints</a:t>
             </a:r>
           </a:p>
         </p:txBody>
@@ -21825,11 +21888,20 @@
             <a:r>
               <a:rPr sz="1600" b="1" i="0">
                 <a:solidFill>
+                  <a:srgbClr val="8A6204"/>
+                </a:solidFill>
+                <a:latin typeface="Calibri"/>
+              </a:rPr>
+              <a:t>8.  </a:t>
+            </a:r>
+            <a:r>
+              <a:rPr sz="1600" b="1">
+                <a:solidFill>
                   <a:srgbClr val="144E4C"/>
                 </a:solidFill>
                 <a:latin typeface="Calibri"/>
               </a:rPr>
-              <a:t>8.  Budget &amp; Project Plan</a:t>
+              <a:t>Budget &amp; Project Plan</a:t>
             </a:r>
           </a:p>
         </p:txBody>
@@ -21879,11 +21951,20 @@
             <a:r>
               <a:rPr sz="1600" b="1" i="0">
                 <a:solidFill>
+                  <a:srgbClr val="8A6204"/>
+                </a:solidFill>
+                <a:latin typeface="Calibri"/>
+              </a:rPr>
+              <a:t>9.  </a:t>
+            </a:r>
+            <a:r>
+              <a:rPr sz="1600" b="1">
+                <a:solidFill>
                   <a:srgbClr val="144E4C"/>
                 </a:solidFill>
                 <a:latin typeface="Calibri"/>
               </a:rPr>
-              <a:t>9.  Conclusion &amp; Future Work</a:t>
+              <a:t>Conclusion &amp; Future Work</a:t>
             </a:r>
           </a:p>
         </p:txBody>
@@ -21999,7 +22080,7 @@
             <a:avLst/>
           </a:prstGeom>
           <a:solidFill>
-            <a:srgbClr val="1B7A6E"/>
+            <a:srgbClr val="D99A06"/>
           </a:solidFill>
           <a:ln>
             <a:noFill/>
@@ -22077,7 +22158,7 @@
             <a:avLst/>
           </a:prstGeom>
           <a:solidFill>
-            <a:srgbClr val="1B7A6E"/>
+            <a:srgbClr val="D99A06"/>
           </a:solidFill>
           <a:ln>
             <a:noFill/>
@@ -22221,7 +22302,7 @@
             </a:avLst>
           </a:prstGeom>
           <a:solidFill>
-            <a:srgbClr val="144E4C"/>
+            <a:srgbClr val="D99A06"/>
           </a:solidFill>
           <a:ln>
             <a:noFill/>
@@ -22249,7 +22330,7 @@
             <a:r>
               <a:rPr sz="1600" b="1" i="0">
                 <a:solidFill>
-                  <a:srgbClr val="FFFFFF"/>
+                  <a:srgbClr val="144E4C"/>
                 </a:solidFill>
                 <a:latin typeface="Calibri"/>
               </a:rPr>
@@ -22369,7 +22450,7 @@
             <a:avLst/>
           </a:prstGeom>
           <a:solidFill>
-            <a:srgbClr val="1B7A6E"/>
+            <a:srgbClr val="D99A06"/>
           </a:solidFill>
           <a:ln>
             <a:noFill/>
@@ -22447,7 +22528,7 @@
             <a:avLst/>
           </a:prstGeom>
           <a:solidFill>
-            <a:srgbClr val="1B7A6E"/>
+            <a:srgbClr val="D99A06"/>
           </a:solidFill>
           <a:ln>
             <a:noFill/>
@@ -22685,7 +22766,7 @@
             <a:avLst/>
           </a:prstGeom>
           <a:solidFill>
-            <a:srgbClr val="1B7A6E"/>
+            <a:srgbClr val="D99A06"/>
           </a:solidFill>
           <a:ln>
             <a:noFill/>
@@ -22763,7 +22844,7 @@
             <a:avLst/>
           </a:prstGeom>
           <a:solidFill>
-            <a:srgbClr val="1B7A6E"/>
+            <a:srgbClr val="D99A06"/>
           </a:solidFill>
           <a:ln>
             <a:noFill/>
@@ -22806,7 +22887,7 @@
             <a:avLst/>
           </a:prstGeom>
           <a:solidFill>
-            <a:srgbClr val="1B7A6E"/>
+            <a:srgbClr val="D99A06"/>
           </a:solidFill>
           <a:ln>
             <a:noFill/>
@@ -22900,7 +22981,7 @@
             <a:avLst/>
           </a:prstGeom>
           <a:solidFill>
-            <a:srgbClr val="1B7A6E"/>
+            <a:srgbClr val="D99A06"/>
           </a:solidFill>
           <a:ln>
             <a:noFill/>
@@ -22994,7 +23075,7 @@
             <a:avLst/>
           </a:prstGeom>
           <a:solidFill>
-            <a:srgbClr val="1B7A6E"/>
+            <a:srgbClr val="D99A06"/>
           </a:solidFill>
           <a:ln>
             <a:noFill/>
@@ -23088,7 +23169,7 @@
             <a:avLst/>
           </a:prstGeom>
           <a:solidFill>
-            <a:srgbClr val="1B7A6E"/>
+            <a:srgbClr val="D99A06"/>
           </a:solidFill>
           <a:ln>
             <a:noFill/>
@@ -23182,7 +23263,7 @@
             <a:avLst/>
           </a:prstGeom>
           <a:solidFill>
-            <a:srgbClr val="1B7A6E"/>
+            <a:srgbClr val="D99A06"/>
           </a:solidFill>
           <a:ln>
             <a:noFill/>
@@ -23372,7 +23453,7 @@
             <a:avLst/>
           </a:prstGeom>
           <a:solidFill>
-            <a:srgbClr val="1B7A6E"/>
+            <a:srgbClr val="D99A06"/>
           </a:solidFill>
           <a:ln>
             <a:noFill/>
@@ -23450,7 +23531,7 @@
             <a:avLst/>
           </a:prstGeom>
           <a:solidFill>
-            <a:srgbClr val="1B7A6E"/>
+            <a:srgbClr val="D99A06"/>
           </a:solidFill>
           <a:ln>
             <a:noFill/>
@@ -23540,7 +23621,7 @@
             <a:avLst/>
           </a:prstGeom>
           <a:solidFill>
-            <a:srgbClr val="1B7A6E"/>
+            <a:srgbClr val="D99A06"/>
           </a:solidFill>
           <a:ln>
             <a:noFill/>
@@ -23583,7 +23664,7 @@
             <a:avLst/>
           </a:prstGeom>
           <a:solidFill>
-            <a:srgbClr val="1B7A6E"/>
+            <a:srgbClr val="D99A06"/>
           </a:solidFill>
           <a:ln>
             <a:noFill/>
@@ -23740,7 +23821,7 @@
             <a:avLst/>
           </a:prstGeom>
           <a:solidFill>
-            <a:srgbClr val="1B7A6E"/>
+            <a:srgbClr val="D99A06"/>
           </a:solidFill>
           <a:ln>
             <a:noFill/>
@@ -23783,7 +23864,7 @@
             <a:avLst/>
           </a:prstGeom>
           <a:solidFill>
-            <a:srgbClr val="1B7A6E"/>
+            <a:srgbClr val="D99A06"/>
           </a:solidFill>
           <a:ln>
             <a:noFill/>
@@ -23940,7 +24021,7 @@
             <a:avLst/>
           </a:prstGeom>
           <a:solidFill>
-            <a:srgbClr val="1B7A6E"/>
+            <a:srgbClr val="D99A06"/>
           </a:solidFill>
           <a:ln>
             <a:noFill/>
@@ -23983,7 +24064,7 @@
             <a:avLst/>
           </a:prstGeom>
           <a:solidFill>
-            <a:srgbClr val="1B7A6E"/>
+            <a:srgbClr val="D99A06"/>
           </a:solidFill>
           <a:ln>
             <a:noFill/>
@@ -24140,7 +24221,7 @@
             <a:avLst/>
           </a:prstGeom>
           <a:solidFill>
-            <a:srgbClr val="1B7A6E"/>
+            <a:srgbClr val="D99A06"/>
           </a:solidFill>
           <a:ln>
             <a:noFill/>
@@ -24183,7 +24264,7 @@
             <a:avLst/>
           </a:prstGeom>
           <a:solidFill>
-            <a:srgbClr val="1B7A6E"/>
+            <a:srgbClr val="D99A06"/>
           </a:solidFill>
           <a:ln>
             <a:noFill/>
@@ -24340,7 +24421,7 @@
             <a:avLst/>
           </a:prstGeom>
           <a:solidFill>
-            <a:srgbClr val="1B7A6E"/>
+            <a:srgbClr val="D99A06"/>
           </a:solidFill>
           <a:ln>
             <a:noFill/>
@@ -24383,7 +24464,7 @@
             <a:avLst/>
           </a:prstGeom>
           <a:solidFill>
-            <a:srgbClr val="1B7A6E"/>
+            <a:srgbClr val="D99A06"/>
           </a:solidFill>
           <a:ln>
             <a:noFill/>
@@ -24540,7 +24621,7 @@
             <a:avLst/>
           </a:prstGeom>
           <a:solidFill>
-            <a:srgbClr val="1B7A6E"/>
+            <a:srgbClr val="D99A06"/>
           </a:solidFill>
           <a:ln>
             <a:noFill/>
@@ -24583,7 +24664,7 @@
             <a:avLst/>
           </a:prstGeom>
           <a:solidFill>
-            <a:srgbClr val="1B7A6E"/>
+            <a:srgbClr val="D99A06"/>
           </a:solidFill>
           <a:ln>
             <a:noFill/>
@@ -24789,7 +24870,7 @@
             <a:avLst/>
           </a:prstGeom>
           <a:solidFill>
-            <a:srgbClr val="1B7A6E"/>
+            <a:srgbClr val="D99A06"/>
           </a:solidFill>
           <a:ln>
             <a:noFill/>
@@ -24867,7 +24948,7 @@
             <a:avLst/>
           </a:prstGeom>
           <a:solidFill>
-            <a:srgbClr val="1B7A6E"/>
+            <a:srgbClr val="D99A06"/>
           </a:solidFill>
           <a:ln>
             <a:noFill/>
@@ -25530,7 +25611,7 @@
             <a:avLst/>
           </a:prstGeom>
           <a:solidFill>
-            <a:srgbClr val="1B7A6E"/>
+            <a:srgbClr val="D99A06"/>
           </a:solidFill>
           <a:ln>
             <a:noFill/>
@@ -25608,7 +25689,7 @@
             <a:avLst/>
           </a:prstGeom>
           <a:solidFill>
-            <a:srgbClr val="1B7A6E"/>
+            <a:srgbClr val="D99A06"/>
           </a:solidFill>
           <a:ln>
             <a:noFill/>
@@ -25651,7 +25732,7 @@
             <a:avLst/>
           </a:prstGeom>
           <a:solidFill>
-            <a:srgbClr val="1B7A6E"/>
+            <a:srgbClr val="D99A06"/>
           </a:solidFill>
           <a:ln>
             <a:noFill/>
@@ -25679,7 +25760,7 @@
             <a:r>
               <a:rPr sz="1500" b="1" i="0">
                 <a:solidFill>
-                  <a:srgbClr val="FFFFFF"/>
+                  <a:srgbClr val="144E4C"/>
                 </a:solidFill>
                 <a:latin typeface="Calibri"/>
               </a:rPr>
@@ -25745,7 +25826,7 @@
             <a:avLst/>
           </a:prstGeom>
           <a:solidFill>
-            <a:srgbClr val="1B7A6E"/>
+            <a:srgbClr val="D99A06"/>
           </a:solidFill>
           <a:ln>
             <a:noFill/>
@@ -25773,7 +25854,7 @@
             <a:r>
               <a:rPr sz="1500" b="1" i="0">
                 <a:solidFill>
-                  <a:srgbClr val="FFFFFF"/>
+                  <a:srgbClr val="144E4C"/>
                 </a:solidFill>
                 <a:latin typeface="Calibri"/>
               </a:rPr>
@@ -25839,7 +25920,7 @@
             <a:avLst/>
           </a:prstGeom>
           <a:solidFill>
-            <a:srgbClr val="1B7A6E"/>
+            <a:srgbClr val="D99A06"/>
           </a:solidFill>
           <a:ln>
             <a:noFill/>
@@ -25867,7 +25948,7 @@
             <a:r>
               <a:rPr sz="1500" b="1" i="0">
                 <a:solidFill>
-                  <a:srgbClr val="FFFFFF"/>
+                  <a:srgbClr val="144E4C"/>
                 </a:solidFill>
                 <a:latin typeface="Calibri"/>
               </a:rPr>
@@ -25933,7 +26014,7 @@
             <a:avLst/>
           </a:prstGeom>
           <a:solidFill>
-            <a:srgbClr val="1B7A6E"/>
+            <a:srgbClr val="D99A06"/>
           </a:solidFill>
           <a:ln>
             <a:noFill/>
@@ -25961,7 +26042,7 @@
             <a:r>
               <a:rPr sz="1500" b="1" i="0">
                 <a:solidFill>
-                  <a:srgbClr val="FFFFFF"/>
+                  <a:srgbClr val="144E4C"/>
                 </a:solidFill>
                 <a:latin typeface="Calibri"/>
               </a:rPr>

</xml_diff>

<commit_message>
docs(slides): slide-18 separates formula banner from Ds input box
</commit_message>
<xml_diff>
--- a/slides/FYDP-I_Defect-to-Delivery.pptx
+++ b/slides/FYDP-I_Defect-to-Delivery.pptx
@@ -11529,8 +11529,8 @@
         </p:nvSpPr>
         <p:spPr>
           <a:xfrm>
-            <a:off x="640080" y="1645920"/>
-            <a:ext cx="1920240" cy="914400"/>
+            <a:off x="640080" y="1554480"/>
+            <a:ext cx="1920240" cy="868680"/>
           </a:xfrm>
           <a:prstGeom prst="roundRect">
             <a:avLst>
@@ -11588,8 +11588,8 @@
         </p:nvSpPr>
         <p:spPr>
           <a:xfrm>
-            <a:off x="640080" y="2788920"/>
-            <a:ext cx="1920240" cy="914400"/>
+            <a:off x="640080" y="2606040"/>
+            <a:ext cx="1920240" cy="868680"/>
           </a:xfrm>
           <a:prstGeom prst="roundRect">
             <a:avLst>
@@ -11647,8 +11647,8 @@
         </p:nvSpPr>
         <p:spPr>
           <a:xfrm>
-            <a:off x="640080" y="3931920"/>
-            <a:ext cx="1920240" cy="914400"/>
+            <a:off x="640080" y="3657600"/>
+            <a:ext cx="1920240" cy="868680"/>
           </a:xfrm>
           <a:prstGeom prst="roundRect">
             <a:avLst>
@@ -11706,7 +11706,7 @@
         </p:nvSpPr>
         <p:spPr>
           <a:xfrm>
-            <a:off x="3108960" y="2468880"/>
+            <a:off x="3108960" y="2377440"/>
             <a:ext cx="2194560" cy="1188720"/>
           </a:xfrm>
           <a:prstGeom prst="roundRect">
@@ -11765,7 +11765,7 @@
         </p:nvSpPr>
         <p:spPr>
           <a:xfrm>
-            <a:off x="5852160" y="2468880"/>
+            <a:off x="5852160" y="2377440"/>
             <a:ext cx="2011680" cy="1188720"/>
           </a:xfrm>
           <a:prstGeom prst="roundRect">
@@ -11824,7 +11824,7 @@
         </p:nvSpPr>
         <p:spPr>
           <a:xfrm>
-            <a:off x="8412480" y="2468880"/>
+            <a:off x="8412480" y="2377440"/>
             <a:ext cx="2743200" cy="1188720"/>
           </a:xfrm>
           <a:prstGeom prst="roundRect">
@@ -11883,8 +11883,8 @@
         </p:nvCxnSpPr>
         <p:spPr>
           <a:xfrm>
-            <a:off x="2578608" y="2103120"/>
-            <a:ext cx="512064" cy="594360"/>
+            <a:off x="2578608" y="1984248"/>
+            <a:ext cx="512064" cy="667512"/>
           </a:xfrm>
           <a:prstGeom prst="line">
             <a:avLst/>
@@ -11919,8 +11919,8 @@
         </p:nvCxnSpPr>
         <p:spPr>
           <a:xfrm flipV="1">
-            <a:off x="2578608" y="3063240"/>
-            <a:ext cx="512064" cy="182880"/>
+            <a:off x="2578608" y="2971800"/>
+            <a:ext cx="512064" cy="64008"/>
           </a:xfrm>
           <a:prstGeom prst="line">
             <a:avLst/>
@@ -11955,8 +11955,8 @@
         </p:nvCxnSpPr>
         <p:spPr>
           <a:xfrm flipV="1">
-            <a:off x="2578608" y="3429000"/>
-            <a:ext cx="512064" cy="960120"/>
+            <a:off x="2578608" y="3291840"/>
+            <a:ext cx="512064" cy="795528"/>
           </a:xfrm>
           <a:prstGeom prst="line">
             <a:avLst/>
@@ -11991,7 +11991,7 @@
         </p:nvCxnSpPr>
         <p:spPr>
           <a:xfrm>
-            <a:off x="5303520" y="3063240"/>
+            <a:off x="5303520" y="2971800"/>
             <a:ext cx="530352" cy="0"/>
           </a:xfrm>
           <a:prstGeom prst="line">
@@ -12027,7 +12027,7 @@
         </p:nvCxnSpPr>
         <p:spPr>
           <a:xfrm>
-            <a:off x="7863840" y="3063240"/>
+            <a:off x="7863840" y="2971800"/>
             <a:ext cx="530352" cy="0"/>
           </a:xfrm>
           <a:prstGeom prst="line">
@@ -12063,8 +12063,8 @@
         </p:nvSpPr>
         <p:spPr>
           <a:xfrm>
-            <a:off x="1463040" y="4297680"/>
-            <a:ext cx="9235440" cy="777240"/>
+            <a:off x="1463040" y="5029200"/>
+            <a:ext cx="9235440" cy="731520"/>
           </a:xfrm>
           <a:prstGeom prst="roundRect">
             <a:avLst/>
@@ -12115,8 +12115,8 @@
         </p:nvSpPr>
         <p:spPr>
           <a:xfrm>
-            <a:off x="548640" y="5212080"/>
-            <a:ext cx="11064240" cy="640080"/>
+            <a:off x="548640" y="5852160"/>
+            <a:ext cx="11064240" cy="502920"/>
           </a:xfrm>
           <a:prstGeom prst="rect">
             <a:avLst/>
@@ -12131,7 +12131,7 @@
           <a:p>
             <a:pPr algn="ctr"/>
             <a:r>
-              <a:rPr sz="1200" b="0" i="0">
+              <a:rPr sz="1150" b="0" i="0">
                 <a:solidFill>
                   <a:srgbClr val="5B6570"/>
                 </a:solidFill>

</xml_diff>

<commit_message>
Fix taxonomy figure layout (clean tree, correct arrows, slide-safe aspect)
</commit_message>
<xml_diff>
--- a/slides/FYDP-I_Defect-to-Delivery.pptx
+++ b/slides/FYDP-I_Defect-to-Delivery.pptx
@@ -5150,16 +5150,85 @@
           </a:p>
         </p:txBody>
       </p:sp>
+      <p:sp>
+        <p:nvSpPr>
+          <p:cNvPr id="5" name="TextBox 4"/>
+          <p:cNvSpPr txBox="1"/>
+          <p:nvPr/>
+        </p:nvSpPr>
+        <p:spPr>
+          <a:xfrm>
+            <a:off x="548640" y="6419088"/>
+            <a:ext cx="9144000" cy="274320"/>
+          </a:xfrm>
+          <a:prstGeom prst="rect">
+            <a:avLst/>
+          </a:prstGeom>
+          <a:noFill/>
+        </p:spPr>
+        <p:txBody>
+          <a:bodyPr wrap="none">
+            <a:spAutoFit/>
+          </a:bodyPr>
+          <a:lstStyle/>
+          <a:p>
+            <a:r>
+              <a:rPr sz="900">
+                <a:solidFill>
+                  <a:srgbClr val="8A8F98"/>
+                </a:solidFill>
+                <a:latin typeface="Calibri"/>
+              </a:rPr>
+              <a:t>Defect-to-Delivery  |  FYDP-I  •  Group: 262-034</a:t>
+            </a:r>
+          </a:p>
+        </p:txBody>
+      </p:sp>
+      <p:sp>
+        <p:nvSpPr>
+          <p:cNvPr id="6" name="TextBox 5"/>
+          <p:cNvSpPr txBox="1"/>
+          <p:nvPr/>
+        </p:nvSpPr>
+        <p:spPr>
+          <a:xfrm>
+            <a:off x="10972800" y="6419088"/>
+            <a:ext cx="640080" cy="274320"/>
+          </a:xfrm>
+          <a:prstGeom prst="rect">
+            <a:avLst/>
+          </a:prstGeom>
+          <a:noFill/>
+        </p:spPr>
+        <p:txBody>
+          <a:bodyPr wrap="none">
+            <a:spAutoFit/>
+          </a:bodyPr>
+          <a:lstStyle/>
+          <a:p>
+            <a:pPr algn="r"/>
+            <a:r>
+              <a:rPr sz="900">
+                <a:solidFill>
+                  <a:srgbClr val="8A8F98"/>
+                </a:solidFill>
+                <a:latin typeface="Calibri"/>
+              </a:rPr>
+              <a:t>11 / 30</a:t>
+            </a:r>
+          </a:p>
+        </p:txBody>
+      </p:sp>
       <p:pic>
         <p:nvPicPr>
-          <p:cNvPr id="4" name="Picture 3" descr="taxonomy.png"/>
+          <p:cNvPr id="7" name="Picture 6" descr="taxonomy.png"/>
           <p:cNvPicPr>
             <a:picLocks noChangeAspect="1"/>
           </p:cNvPicPr>
           <p:nvPr/>
         </p:nvPicPr>
         <p:blipFill>
-          <a:blip r:embed="rId2"/>
+          <a:blip r:embed="rId3"/>
           <a:stretch>
             <a:fillRect/>
           </a:stretch>
@@ -5167,82 +5236,13 @@
         <p:spPr>
           <a:xfrm>
             <a:off x="868680" y="1234440"/>
-            <a:ext cx="10424160" cy="5832065"/>
+            <a:ext cx="10424160" cy="3911016"/>
           </a:xfrm>
           <a:prstGeom prst="rect">
             <a:avLst/>
           </a:prstGeom>
         </p:spPr>
       </p:pic>
-      <p:sp>
-        <p:nvSpPr>
-          <p:cNvPr id="5" name="TextBox 4"/>
-          <p:cNvSpPr txBox="1"/>
-          <p:nvPr/>
-        </p:nvSpPr>
-        <p:spPr>
-          <a:xfrm>
-            <a:off x="548640" y="6419088"/>
-            <a:ext cx="9144000" cy="274320"/>
-          </a:xfrm>
-          <a:prstGeom prst="rect">
-            <a:avLst/>
-          </a:prstGeom>
-          <a:noFill/>
-        </p:spPr>
-        <p:txBody>
-          <a:bodyPr wrap="none">
-            <a:spAutoFit/>
-          </a:bodyPr>
-          <a:lstStyle/>
-          <a:p>
-            <a:r>
-              <a:rPr sz="900">
-                <a:solidFill>
-                  <a:srgbClr val="8A8F98"/>
-                </a:solidFill>
-                <a:latin typeface="Calibri"/>
-              </a:rPr>
-              <a:t>Defect-to-Delivery  |  FYDP-I  •  Group: 262-034</a:t>
-            </a:r>
-          </a:p>
-        </p:txBody>
-      </p:sp>
-      <p:sp>
-        <p:nvSpPr>
-          <p:cNvPr id="6" name="TextBox 5"/>
-          <p:cNvSpPr txBox="1"/>
-          <p:nvPr/>
-        </p:nvSpPr>
-        <p:spPr>
-          <a:xfrm>
-            <a:off x="10972800" y="6419088"/>
-            <a:ext cx="640080" cy="274320"/>
-          </a:xfrm>
-          <a:prstGeom prst="rect">
-            <a:avLst/>
-          </a:prstGeom>
-          <a:noFill/>
-        </p:spPr>
-        <p:txBody>
-          <a:bodyPr wrap="none">
-            <a:spAutoFit/>
-          </a:bodyPr>
-          <a:lstStyle/>
-          <a:p>
-            <a:pPr algn="r"/>
-            <a:r>
-              <a:rPr sz="900">
-                <a:solidFill>
-                  <a:srgbClr val="8A8F98"/>
-                </a:solidFill>
-                <a:latin typeface="Calibri"/>
-              </a:rPr>
-              <a:t>11 / 30</a:t>
-            </a:r>
-          </a:p>
-        </p:txBody>
-      </p:sp>
     </p:spTree>
   </p:cSld>
   <p:clrMapOvr>

</xml_diff>

<commit_message>
Fix deck/report cross-reference and name mismatches
- Correct figure refs to report List of Figures (Fig 3.1/3.2/3.4/3.5/3.6, Gantt Fig 5.1)
- Replace dangling 'Sec 3.2.8' reference (no such section) with Report Fig. 3.6
- Align names with report author list: Ms. Riya Akter Satu, Mohammad Amin,
  Mustafizur Rahman Murad
- Align slide 2 role cards to report Table 3.8 task allocation
</commit_message>
<xml_diff>
--- a/slides/FYDP-I_Defect-to-Delivery.pptx
+++ b/slides/FYDP-I_Defect-to-Delivery.pptx
@@ -7955,7 +7955,7 @@
                 </a:solidFill>
                 <a:latin typeface="Calibri"/>
               </a:rPr>
-              <a:t>▪  Table 3.1 Coverage Grouped Into FR1–FR6 And NFR1–NFR6 (See Report §3.1); Grading Per §3.2.8.</a:t>
+              <a:t>▪  Table 3.1 Coverage Grouped Into FR1–FR6 And NFR1–NFR6 (See Report §3.1); Grading Per Report Fig. 3.6.</a:t>
             </a:r>
           </a:p>
         </p:txBody>
@@ -10179,7 +10179,7 @@
                 </a:solidFill>
                 <a:latin typeface="Georgia"/>
               </a:rPr>
-              <a:t>Proposed System Diagram (Fig. 3.2)</a:t>
+              <a:t>Proposed System Diagram (Fig. 3.1)</a:t>
             </a:r>
           </a:p>
         </p:txBody>
@@ -11115,7 +11115,7 @@
                 </a:solidFill>
                 <a:latin typeface="Georgia"/>
               </a:rPr>
-              <a:t>System Workflow (Fig. 3.5)</a:t>
+              <a:t>System Workflow (Fig. 3.2)</a:t>
             </a:r>
           </a:p>
         </p:txBody>
@@ -12754,7 +12754,7 @@
                 </a:solidFill>
                 <a:latin typeface="Calibri"/>
               </a:rPr>
-              <a:t>Problem, Motivation &amp; Objectives</a:t>
+              <a:t>Baseline Reproduction, YOLO Training &amp; Lead-Time Model</a:t>
             </a:r>
           </a:p>
         </p:txBody>
@@ -12973,7 +12973,7 @@
                 </a:solidFill>
                 <a:latin typeface="Calibri"/>
               </a:rPr>
-              <a:t>Literature &amp; Gap Analysis</a:t>
+              <a:t>Dataset Audit, Split &amp; Edge Deployment</a:t>
             </a:r>
           </a:p>
         </p:txBody>
@@ -13154,7 +13154,7 @@
                 </a:solidFill>
                 <a:latin typeface="Calibri"/>
               </a:rPr>
-              <a:t>MST Riya Akter Satu</a:t>
+              <a:t>Ms. Riya Akter Satu</a:t>
             </a:r>
           </a:p>
           <a:p>
@@ -13192,7 +13192,7 @@
                 </a:solidFill>
                 <a:latin typeface="Calibri"/>
               </a:rPr>
-              <a:t>Requirement Analysis &amp; Dataset Audit</a:t>
+              <a:t>Requirement Analysis, Preprocessing &amp; Report Writing</a:t>
             </a:r>
           </a:p>
         </p:txBody>
@@ -13411,7 +13411,7 @@
                 </a:solidFill>
                 <a:latin typeface="Calibri"/>
               </a:rPr>
-              <a:t>System Design &amp; Diagrams</a:t>
+              <a:t>Few-Shot Anomaly Detection (PatchCore / DINOv2)</a:t>
             </a:r>
           </a:p>
         </p:txBody>
@@ -13630,7 +13630,7 @@
                 </a:solidFill>
                 <a:latin typeface="Calibri"/>
               </a:rPr>
-              <a:t>Standards, Constraints, Budget &amp; Project Plan</a:t>
+              <a:t>Metadata Bridge, Defect Density Score &amp; Dashboard</a:t>
             </a:r>
           </a:p>
         </p:txBody>
@@ -13849,7 +13849,7 @@
                 </a:solidFill>
                 <a:latin typeface="Calibri"/>
               </a:rPr>
-              <a:t>Complex Engineering Problem, Task Allocation &amp; Conclusion</a:t>
+              <a:t>Testing &amp; Evaluation</a:t>
             </a:r>
           </a:p>
         </p:txBody>
@@ -14023,7 +14023,7 @@
                 </a:solidFill>
                 <a:latin typeface="Georgia"/>
               </a:rPr>
-              <a:t>Metadata Bridge (Fig. 3.6)</a:t>
+              <a:t>Metadata Bridge (Fig. 3.4)</a:t>
             </a:r>
           </a:p>
         </p:txBody>
@@ -15363,7 +15363,7 @@
                 </a:solidFill>
                 <a:latin typeface="Georgia"/>
               </a:rPr>
-              <a:t>Machine Learning Pipeline (Fig. 3.7)</a:t>
+              <a:t>Machine Learning Pipeline (Fig. 3.5)</a:t>
             </a:r>
           </a:p>
         </p:txBody>
@@ -16201,7 +16201,7 @@
                 </a:solidFill>
                 <a:latin typeface="Georgia"/>
               </a:rPr>
-              <a:t>Four-Point Inspection Grading (Fig. 3.8)</a:t>
+              <a:t>Four-Point Inspection Grading (Fig. 3.6)</a:t>
             </a:r>
           </a:p>
         </p:txBody>
@@ -19537,7 +19537,7 @@
                 </a:solidFill>
                 <a:latin typeface="Georgia"/>
               </a:rPr>
-              <a:t>Project Plan (Table 3.7; Gantt: Fig. 3.9)</a:t>
+              <a:t>Project Plan (Table 3.7; Gantt: Fig. 5.1)</a:t>
             </a:r>
           </a:p>
         </p:txBody>
@@ -19615,7 +19615,7 @@
                 </a:solidFill>
                 <a:latin typeface="Calibri"/>
               </a:rPr>
-              <a:t>Audit / Split (Done) → Reproduction → Segmentation → Anomaly → Planning → Edge → Write-Up, Over 32 Weeks. Full Gantt: Report Fig. 3.9.</a:t>
+              <a:t>Audit / Split (Done) → Reproduction → Segmentation → Anomaly → Planning → Edge → Write-Up, Over 32 Weeks. Full Gantt: Report Fig. 5.1.</a:t>
             </a:r>
           </a:p>
         </p:txBody>
@@ -22186,7 +22186,7 @@
                           </a:solidFill>
                           <a:latin typeface="Calibri"/>
                         </a:rPr>
-                        <a:t>MST Riya Akter Satu</a:t>
+                        <a:t>Ms. Riya Akter Satu</a:t>
                       </a:r>
                     </a:p>
                   </a:txBody>
@@ -22234,7 +22234,7 @@
                           </a:solidFill>
                           <a:latin typeface="Calibri"/>
                         </a:rPr>
-                        <a:t>Mohammed Amin</a:t>
+                        <a:t>Mohammad Amin</a:t>
                       </a:r>
                     </a:p>
                   </a:txBody>
@@ -22330,7 +22330,7 @@
                           </a:solidFill>
                           <a:latin typeface="Calibri"/>
                         </a:rPr>
-                        <a:t>Md. Mostafizur Rahman Murad</a:t>
+                        <a:t>Mustafizur Rahman Murad</a:t>
                       </a:r>
                     </a:p>
                   </a:txBody>

</xml_diff>

<commit_message>
Remove deck claims not supported by the report
- Slide 9: drop unsourced 99.6% MVTec AUROC and 89-96% few-shot figures;
  report 2.1.3 describes these qualitatively only
- Slide 21: drop invented closed-form lead-time equation and its derived
  40% inflation claim; report Fig 3.5 specifies no equation
</commit_message>
<xml_diff>
--- a/slides/FYDP-I_Defect-to-Delivery.pptx
+++ b/slides/FYDP-I_Defect-to-Delivery.pptx
@@ -15992,7 +15992,7 @@
                 </a:solidFill>
                 <a:latin typeface="Calibri"/>
               </a:rPr>
-              <a:t>Lead = (Qty / Speed) × 0.1 × (1 + 2 × Ds)</a:t>
+              <a:t>Lead = f(Speed, Quantity, Ds)  [Random Forest]</a:t>
             </a:r>
           </a:p>
         </p:txBody>
@@ -16027,7 +16027,7 @@
                 </a:solidFill>
                 <a:latin typeface="Calibri"/>
               </a:rPr>
-              <a:t>Example: Ds = 0.2 Inflates Predicted Time By 40%. Features: Speed 20–100 m/min, Quantity 100–10,000, Ds 0–0.5, 100-Tree Random Forest, Evaluated Vs Static-Mean And No-Ds Baselines.</a:t>
+              <a:t>Ds Raises Predicted Lead Time; Evaluated Vs Static-Mean And No-Ds Baselines. Features: Speed 20–100 m/min, Quantity 100–10,000, Ds 0–0.5, 100-Tree Random Forest.</a:t>
             </a:r>
           </a:p>
         </p:txBody>
@@ -27932,7 +27932,7 @@
                 </a:solidFill>
                 <a:latin typeface="Calibri"/>
               </a:rPr>
-              <a:t>PatchCore (99.6% MVTec AUROC), Reverse Distillation (Low Latency), AnomalyDINO / PatchEAD Reach 89–96% With A Handful Of Good Samples And No Defect Labels.</a:t>
+              <a:t>PatchCore (Patch Memory Bank, Strong MVTec Performance), Reverse Distillation (Fast Inference), AnomalyDINO / PatchEAD Detect Defects With A Handful Of Good Samples And No Defect Labels.</a:t>
             </a:r>
           </a:p>
         </p:txBody>

</xml_diff>

<commit_message>
Re-align deck figure refs to submitted PDF (authoritative over markdown)
The committed markdown report diverges from the submitted 27-Sept PDF:
- PDF List of Figures: 3.2 System Diagram, 3.5 Workflow, 3.6 Metadata Bridge,
  3.7 ML Pipeline, 3.8 Four-Point, 3.9 Gantt. Restore deck to PDF numbering.
- Sec 3.2.8 Four-Point Inspection Grading Logic DOES exist; restore reference.
- Lead-time equation IS in report (p13): restore Lead = (Qty/Speed) x 0.1 x
  (1 + 2 x Ds) and the Ds=0.2 => +40% example.

Kept from prior pass (confirmed against PDF): names, slide 2 roles per Table 3.8,
and removal of 99.6% AUROC / 89-96% claims which appear 0 times in the PDF.
</commit_message>
<xml_diff>
--- a/slides/FYDP-I_Defect-to-Delivery.pptx
+++ b/slides/FYDP-I_Defect-to-Delivery.pptx
@@ -7955,7 +7955,7 @@
                 </a:solidFill>
                 <a:latin typeface="Calibri"/>
               </a:rPr>
-              <a:t>▪  Table 3.1 Coverage Grouped Into FR1–FR6 And NFR1–NFR6 (See Report §3.1); Grading Per Report Fig. 3.6.</a:t>
+              <a:t>▪  Table 3.1 Coverage Grouped Into FR1–FR6 And NFR1–NFR6 (See Report §3.1); Grading Per §3.2.8.</a:t>
             </a:r>
           </a:p>
         </p:txBody>
@@ -10179,7 +10179,7 @@
                 </a:solidFill>
                 <a:latin typeface="Georgia"/>
               </a:rPr>
-              <a:t>Proposed System Diagram (Fig. 3.1)</a:t>
+              <a:t>Proposed System Diagram (Fig. 3.2)</a:t>
             </a:r>
           </a:p>
         </p:txBody>
@@ -11115,7 +11115,7 @@
                 </a:solidFill>
                 <a:latin typeface="Georgia"/>
               </a:rPr>
-              <a:t>System Workflow (Fig. 3.2)</a:t>
+              <a:t>System Workflow (Fig. 3.5)</a:t>
             </a:r>
           </a:p>
         </p:txBody>
@@ -14023,7 +14023,7 @@
                 </a:solidFill>
                 <a:latin typeface="Georgia"/>
               </a:rPr>
-              <a:t>Metadata Bridge (Fig. 3.4)</a:t>
+              <a:t>Metadata Bridge (Fig. 3.6)</a:t>
             </a:r>
           </a:p>
         </p:txBody>
@@ -15363,7 +15363,7 @@
                 </a:solidFill>
                 <a:latin typeface="Georgia"/>
               </a:rPr>
-              <a:t>Machine Learning Pipeline (Fig. 3.5)</a:t>
+              <a:t>Machine Learning Pipeline (Fig. 3.7)</a:t>
             </a:r>
           </a:p>
         </p:txBody>
@@ -15992,7 +15992,7 @@
                 </a:solidFill>
                 <a:latin typeface="Calibri"/>
               </a:rPr>
-              <a:t>Lead = f(Speed, Quantity, Ds)  [Random Forest]</a:t>
+              <a:t>Lead = (Qty / Speed) × 0.1 × (1 + 2 × Ds)</a:t>
             </a:r>
           </a:p>
         </p:txBody>
@@ -16027,7 +16027,7 @@
                 </a:solidFill>
                 <a:latin typeface="Calibri"/>
               </a:rPr>
-              <a:t>Ds Raises Predicted Lead Time; Evaluated Vs Static-Mean And No-Ds Baselines. Features: Speed 20–100 m/min, Quantity 100–10,000, Ds 0–0.5, 100-Tree Random Forest.</a:t>
+              <a:t>Example: Ds = 0.2 Inflates Predicted Time By 40%. Features: Speed 20–100 m/min, Quantity 100–10,000, Ds 0–0.5, 100-Tree Random Forest, Evaluated Vs Static-Mean And No-Ds Baselines.</a:t>
             </a:r>
           </a:p>
         </p:txBody>
@@ -16201,7 +16201,7 @@
                 </a:solidFill>
                 <a:latin typeface="Georgia"/>
               </a:rPr>
-              <a:t>Four-Point Inspection Grading (Fig. 3.6)</a:t>
+              <a:t>Four-Point Inspection Grading (Fig. 3.8)</a:t>
             </a:r>
           </a:p>
         </p:txBody>
@@ -19537,7 +19537,7 @@
                 </a:solidFill>
                 <a:latin typeface="Georgia"/>
               </a:rPr>
-              <a:t>Project Plan (Table 3.7; Gantt: Fig. 5.1)</a:t>
+              <a:t>Project Plan (Table 3.7; Gantt: Fig. 3.9)</a:t>
             </a:r>
           </a:p>
         </p:txBody>
@@ -19615,7 +19615,7 @@
                 </a:solidFill>
                 <a:latin typeface="Calibri"/>
               </a:rPr>
-              <a:t>Audit / Split (Done) → Reproduction → Segmentation → Anomaly → Planning → Edge → Write-Up, Over 32 Weeks. Full Gantt: Report Fig. 5.1.</a:t>
+              <a:t>Audit / Split (Done) → Reproduction → Segmentation → Anomaly → Planning → Edge → Write-Up, Over 32 Weeks. Full Gantt: Report Fig. 3.9.</a:t>
             </a:r>
           </a:p>
         </p:txBody>

</xml_diff>